<commit_message>
Use POST for /scan and fixed the email body extractor to use tree walker
Change background worker to POST email_words_list as JSON to /scan (remove URL-encoding), and remove some debug console logs. Update server app to accept POST and read JSON payload. Improve highlighter: add Clean_Email_Body to extract visible text excluding link hrefs, normalize to lowercase before scanning, adjust regex escaping, and use result for highlighting. UI tweaks: comment out scraper/getHTML buttons and related handlers, update button existence checks. Minor cleanup. Also add/modify several project doc and temporary files.
</commit_message>
<xml_diff>
--- a/COMP 3000/Project Docs/Process diagram.pptx
+++ b/COMP 3000/Project Docs/Process diagram.pptx
@@ -8,6 +8,8 @@
     <p:sldId id="256" r:id="rId2"/>
     <p:sldId id="257" r:id="rId3"/>
     <p:sldId id="258" r:id="rId4"/>
+    <p:sldId id="259" r:id="rId5"/>
+    <p:sldId id="260" r:id="rId6"/>
   </p:sldIdLst>
   <p:sldSz cx="12192000" cy="6858000"/>
   <p:notesSz cx="6858000" cy="9144000"/>
@@ -263,7 +265,7 @@
           <a:p>
             <a:fld id="{E239C3FF-4299-45FA-A552-BB98A650FEDD}" type="datetimeFigureOut">
               <a:rPr lang="en-GB" smtClean="0"/>
-              <a:t>19/11/2025</a:t>
+              <a:t>07/03/2026</a:t>
             </a:fld>
             <a:endParaRPr lang="en-GB"/>
           </a:p>
@@ -463,7 +465,7 @@
           <a:p>
             <a:fld id="{E239C3FF-4299-45FA-A552-BB98A650FEDD}" type="datetimeFigureOut">
               <a:rPr lang="en-GB" smtClean="0"/>
-              <a:t>19/11/2025</a:t>
+              <a:t>07/03/2026</a:t>
             </a:fld>
             <a:endParaRPr lang="en-GB"/>
           </a:p>
@@ -673,7 +675,7 @@
           <a:p>
             <a:fld id="{E239C3FF-4299-45FA-A552-BB98A650FEDD}" type="datetimeFigureOut">
               <a:rPr lang="en-GB" smtClean="0"/>
-              <a:t>19/11/2025</a:t>
+              <a:t>07/03/2026</a:t>
             </a:fld>
             <a:endParaRPr lang="en-GB"/>
           </a:p>
@@ -873,7 +875,7 @@
           <a:p>
             <a:fld id="{E239C3FF-4299-45FA-A552-BB98A650FEDD}" type="datetimeFigureOut">
               <a:rPr lang="en-GB" smtClean="0"/>
-              <a:t>19/11/2025</a:t>
+              <a:t>07/03/2026</a:t>
             </a:fld>
             <a:endParaRPr lang="en-GB"/>
           </a:p>
@@ -1149,7 +1151,7 @@
           <a:p>
             <a:fld id="{E239C3FF-4299-45FA-A552-BB98A650FEDD}" type="datetimeFigureOut">
               <a:rPr lang="en-GB" smtClean="0"/>
-              <a:t>19/11/2025</a:t>
+              <a:t>07/03/2026</a:t>
             </a:fld>
             <a:endParaRPr lang="en-GB"/>
           </a:p>
@@ -1417,7 +1419,7 @@
           <a:p>
             <a:fld id="{E239C3FF-4299-45FA-A552-BB98A650FEDD}" type="datetimeFigureOut">
               <a:rPr lang="en-GB" smtClean="0"/>
-              <a:t>19/11/2025</a:t>
+              <a:t>07/03/2026</a:t>
             </a:fld>
             <a:endParaRPr lang="en-GB"/>
           </a:p>
@@ -1832,7 +1834,7 @@
           <a:p>
             <a:fld id="{E239C3FF-4299-45FA-A552-BB98A650FEDD}" type="datetimeFigureOut">
               <a:rPr lang="en-GB" smtClean="0"/>
-              <a:t>19/11/2025</a:t>
+              <a:t>07/03/2026</a:t>
             </a:fld>
             <a:endParaRPr lang="en-GB"/>
           </a:p>
@@ -1974,7 +1976,7 @@
           <a:p>
             <a:fld id="{E239C3FF-4299-45FA-A552-BB98A650FEDD}" type="datetimeFigureOut">
               <a:rPr lang="en-GB" smtClean="0"/>
-              <a:t>19/11/2025</a:t>
+              <a:t>07/03/2026</a:t>
             </a:fld>
             <a:endParaRPr lang="en-GB"/>
           </a:p>
@@ -2087,7 +2089,7 @@
           <a:p>
             <a:fld id="{E239C3FF-4299-45FA-A552-BB98A650FEDD}" type="datetimeFigureOut">
               <a:rPr lang="en-GB" smtClean="0"/>
-              <a:t>19/11/2025</a:t>
+              <a:t>07/03/2026</a:t>
             </a:fld>
             <a:endParaRPr lang="en-GB"/>
           </a:p>
@@ -2400,7 +2402,7 @@
           <a:p>
             <a:fld id="{E239C3FF-4299-45FA-A552-BB98A650FEDD}" type="datetimeFigureOut">
               <a:rPr lang="en-GB" smtClean="0"/>
-              <a:t>19/11/2025</a:t>
+              <a:t>07/03/2026</a:t>
             </a:fld>
             <a:endParaRPr lang="en-GB"/>
           </a:p>
@@ -2689,7 +2691,7 @@
           <a:p>
             <a:fld id="{E239C3FF-4299-45FA-A552-BB98A650FEDD}" type="datetimeFigureOut">
               <a:rPr lang="en-GB" smtClean="0"/>
-              <a:t>19/11/2025</a:t>
+              <a:t>07/03/2026</a:t>
             </a:fld>
             <a:endParaRPr lang="en-GB"/>
           </a:p>
@@ -2932,7 +2934,7 @@
           <a:p>
             <a:fld id="{E239C3FF-4299-45FA-A552-BB98A650FEDD}" type="datetimeFigureOut">
               <a:rPr lang="en-GB" smtClean="0"/>
-              <a:t>19/11/2025</a:t>
+              <a:t>07/03/2026</a:t>
             </a:fld>
             <a:endParaRPr lang="en-GB"/>
           </a:p>
@@ -5755,7 +5757,7 @@
             <a:pPr algn="ctr"/>
             <a:r>
               <a:rPr lang="en-GB" dirty="0"/>
-              <a:t>How to get text</a:t>
+              <a:t>How to highlight v1</a:t>
             </a:r>
           </a:p>
         </p:txBody>
@@ -5774,7 +5776,7 @@
         </p:nvSpPr>
         <p:spPr>
           <a:xfrm>
-            <a:off x="4096512" y="1271016"/>
+            <a:off x="4096512" y="1504438"/>
             <a:ext cx="2194560" cy="731520"/>
           </a:xfrm>
           <a:prstGeom prst="rect">
@@ -5804,7 +5806,7 @@
             <a:pPr algn="ctr"/>
             <a:r>
               <a:rPr lang="en-GB" dirty="0"/>
-              <a:t>Gmail email</a:t>
+              <a:t>Identify and Scan email body</a:t>
             </a:r>
           </a:p>
         </p:txBody>
@@ -5823,7 +5825,7 @@
         </p:nvSpPr>
         <p:spPr>
           <a:xfrm>
-            <a:off x="7900416" y="1271016"/>
+            <a:off x="7940040" y="1429973"/>
             <a:ext cx="2194560" cy="731520"/>
           </a:xfrm>
           <a:prstGeom prst="rect">
@@ -5853,7 +5855,7 @@
             <a:pPr algn="ctr"/>
             <a:r>
               <a:rPr lang="en-GB" dirty="0"/>
-              <a:t>&lt;Span&gt;</a:t>
+              <a:t>Identify all words</a:t>
             </a:r>
           </a:p>
         </p:txBody>
@@ -5874,9 +5876,9 @@
           <p:nvPr/>
         </p:nvCxnSpPr>
         <p:spPr>
-          <a:xfrm>
-            <a:off x="6291072" y="1636776"/>
-            <a:ext cx="1609344" cy="0"/>
+          <a:xfrm flipV="1">
+            <a:off x="6291072" y="1795733"/>
+            <a:ext cx="1648968" cy="74465"/>
           </a:xfrm>
           <a:prstGeom prst="straightConnector1">
             <a:avLst/>
@@ -5902,10 +5904,10 @@
       </p:cxnSp>
       <p:sp>
         <p:nvSpPr>
-          <p:cNvPr id="7" name="Rectangle 6">
-            <a:extLst>
-              <a:ext uri="{FF2B5EF4-FFF2-40B4-BE49-F238E27FC236}">
-                <a16:creationId xmlns:a16="http://schemas.microsoft.com/office/drawing/2014/main" id="{28EA107F-FEE7-8583-79B6-1D472FE53011}"/>
+          <p:cNvPr id="27" name="Rectangle 26">
+            <a:extLst>
+              <a:ext uri="{FF2B5EF4-FFF2-40B4-BE49-F238E27FC236}">
+                <a16:creationId xmlns:a16="http://schemas.microsoft.com/office/drawing/2014/main" id="{3DD8C56D-6F30-104C-0AC2-1A3CC42CF1C3}"/>
               </a:ext>
             </a:extLst>
           </p:cNvPr>
@@ -5914,8 +5916,8 @@
         </p:nvSpPr>
         <p:spPr>
           <a:xfrm>
-            <a:off x="7900416" y="3593592"/>
-            <a:ext cx="2194560" cy="941832"/>
+            <a:off x="859536" y="1557178"/>
+            <a:ext cx="1664208" cy="646331"/>
           </a:xfrm>
           <a:prstGeom prst="rect">
             <a:avLst/>
@@ -5944,315 +5946,7 @@
             <a:pPr algn="ctr"/>
             <a:r>
               <a:rPr lang="en-GB" dirty="0"/>
-              <a:t>Email text</a:t>
-            </a:r>
-          </a:p>
-        </p:txBody>
-      </p:sp>
-      <p:cxnSp>
-        <p:nvCxnSpPr>
-          <p:cNvPr id="9" name="Straight Arrow Connector 8">
-            <a:extLst>
-              <a:ext uri="{FF2B5EF4-FFF2-40B4-BE49-F238E27FC236}">
-                <a16:creationId xmlns:a16="http://schemas.microsoft.com/office/drawing/2014/main" id="{95365039-BE85-F03B-F0B1-04C263D559D7}"/>
-              </a:ext>
-            </a:extLst>
-          </p:cNvPr>
-          <p:cNvCxnSpPr>
-            <a:stCxn id="4" idx="2"/>
-            <a:endCxn id="7" idx="0"/>
-          </p:cNvCxnSpPr>
-          <p:nvPr/>
-        </p:nvCxnSpPr>
-        <p:spPr>
-          <a:xfrm>
-            <a:off x="8997696" y="2002536"/>
-            <a:ext cx="0" cy="1591056"/>
-          </a:xfrm>
-          <a:prstGeom prst="straightConnector1">
-            <a:avLst/>
-          </a:prstGeom>
-          <a:ln>
-            <a:tailEnd type="triangle"/>
-          </a:ln>
-        </p:spPr>
-        <p:style>
-          <a:lnRef idx="2">
-            <a:schemeClr val="accent1"/>
-          </a:lnRef>
-          <a:fillRef idx="0">
-            <a:schemeClr val="accent1"/>
-          </a:fillRef>
-          <a:effectRef idx="1">
-            <a:schemeClr val="accent1"/>
-          </a:effectRef>
-          <a:fontRef idx="minor">
-            <a:schemeClr val="tx1"/>
-          </a:fontRef>
-        </p:style>
-      </p:cxnSp>
-      <p:sp>
-        <p:nvSpPr>
-          <p:cNvPr id="14" name="Rectangle 13">
-            <a:extLst>
-              <a:ext uri="{FF2B5EF4-FFF2-40B4-BE49-F238E27FC236}">
-                <a16:creationId xmlns:a16="http://schemas.microsoft.com/office/drawing/2014/main" id="{C134EB65-79C8-620C-1412-D0B023926275}"/>
-              </a:ext>
-            </a:extLst>
-          </p:cNvPr>
-          <p:cNvSpPr/>
-          <p:nvPr/>
-        </p:nvSpPr>
-        <p:spPr>
-          <a:xfrm>
-            <a:off x="4306824" y="3593592"/>
-            <a:ext cx="1984248" cy="941832"/>
-          </a:xfrm>
-          <a:prstGeom prst="rect">
-            <a:avLst/>
-          </a:prstGeom>
-        </p:spPr>
-        <p:style>
-          <a:lnRef idx="2">
-            <a:schemeClr val="accent1">
-              <a:shade val="15000"/>
-            </a:schemeClr>
-          </a:lnRef>
-          <a:fillRef idx="1">
-            <a:schemeClr val="accent1"/>
-          </a:fillRef>
-          <a:effectRef idx="0">
-            <a:schemeClr val="accent1"/>
-          </a:effectRef>
-          <a:fontRef idx="minor">
-            <a:schemeClr val="lt1"/>
-          </a:fontRef>
-        </p:style>
-        <p:txBody>
-          <a:bodyPr rtlCol="0" anchor="ctr"/>
-          <a:lstStyle/>
-          <a:p>
-            <a:pPr algn="ctr"/>
-            <a:r>
-              <a:rPr lang="en-GB" dirty="0"/>
-              <a:t>Text we want</a:t>
-            </a:r>
-          </a:p>
-        </p:txBody>
-      </p:sp>
-      <p:cxnSp>
-        <p:nvCxnSpPr>
-          <p:cNvPr id="16" name="Straight Arrow Connector 15">
-            <a:extLst>
-              <a:ext uri="{FF2B5EF4-FFF2-40B4-BE49-F238E27FC236}">
-                <a16:creationId xmlns:a16="http://schemas.microsoft.com/office/drawing/2014/main" id="{913A3242-D3A6-8A6B-1283-05893CB58663}"/>
-              </a:ext>
-            </a:extLst>
-          </p:cNvPr>
-          <p:cNvCxnSpPr>
-            <a:stCxn id="7" idx="1"/>
-            <a:endCxn id="14" idx="3"/>
-          </p:cNvCxnSpPr>
-          <p:nvPr/>
-        </p:nvCxnSpPr>
-        <p:spPr>
-          <a:xfrm flipH="1">
-            <a:off x="6291072" y="4064508"/>
-            <a:ext cx="1609344" cy="0"/>
-          </a:xfrm>
-          <a:prstGeom prst="straightConnector1">
-            <a:avLst/>
-          </a:prstGeom>
-          <a:ln>
-            <a:tailEnd type="triangle"/>
-          </a:ln>
-        </p:spPr>
-        <p:style>
-          <a:lnRef idx="2">
-            <a:schemeClr val="accent1"/>
-          </a:lnRef>
-          <a:fillRef idx="0">
-            <a:schemeClr val="accent1"/>
-          </a:fillRef>
-          <a:effectRef idx="1">
-            <a:schemeClr val="accent1"/>
-          </a:effectRef>
-          <a:fontRef idx="minor">
-            <a:schemeClr val="tx1"/>
-          </a:fontRef>
-        </p:style>
-      </p:cxnSp>
-      <p:sp>
-        <p:nvSpPr>
-          <p:cNvPr id="17" name="Rectangle 16">
-            <a:extLst>
-              <a:ext uri="{FF2B5EF4-FFF2-40B4-BE49-F238E27FC236}">
-                <a16:creationId xmlns:a16="http://schemas.microsoft.com/office/drawing/2014/main" id="{76F5F1E8-6EFE-3392-CBDE-A8BC907D34D6}"/>
-              </a:ext>
-            </a:extLst>
-          </p:cNvPr>
-          <p:cNvSpPr/>
-          <p:nvPr/>
-        </p:nvSpPr>
-        <p:spPr>
-          <a:xfrm>
-            <a:off x="576072" y="3593592"/>
-            <a:ext cx="2084832" cy="941832"/>
-          </a:xfrm>
-          <a:prstGeom prst="rect">
-            <a:avLst/>
-          </a:prstGeom>
-        </p:spPr>
-        <p:style>
-          <a:lnRef idx="2">
-            <a:schemeClr val="accent1">
-              <a:shade val="15000"/>
-            </a:schemeClr>
-          </a:lnRef>
-          <a:fillRef idx="1">
-            <a:schemeClr val="accent1"/>
-          </a:fillRef>
-          <a:effectRef idx="0">
-            <a:schemeClr val="accent1"/>
-          </a:effectRef>
-          <a:fontRef idx="minor">
-            <a:schemeClr val="lt1"/>
-          </a:fontRef>
-        </p:style>
-        <p:txBody>
-          <a:bodyPr rtlCol="0" anchor="ctr"/>
-          <a:lstStyle/>
-          <a:p>
-            <a:pPr algn="ctr"/>
-            <a:r>
-              <a:rPr lang="en-GB" dirty="0"/>
-              <a:t>Highlight</a:t>
-            </a:r>
-          </a:p>
-        </p:txBody>
-      </p:sp>
-      <p:cxnSp>
-        <p:nvCxnSpPr>
-          <p:cNvPr id="19" name="Straight Arrow Connector 18">
-            <a:extLst>
-              <a:ext uri="{FF2B5EF4-FFF2-40B4-BE49-F238E27FC236}">
-                <a16:creationId xmlns:a16="http://schemas.microsoft.com/office/drawing/2014/main" id="{E818EF1D-D6CE-3845-319E-C1E7C31FDA63}"/>
-              </a:ext>
-            </a:extLst>
-          </p:cNvPr>
-          <p:cNvCxnSpPr>
-            <a:stCxn id="14" idx="1"/>
-            <a:endCxn id="17" idx="3"/>
-          </p:cNvCxnSpPr>
-          <p:nvPr/>
-        </p:nvCxnSpPr>
-        <p:spPr>
-          <a:xfrm flipH="1">
-            <a:off x="2660904" y="4064508"/>
-            <a:ext cx="1645920" cy="0"/>
-          </a:xfrm>
-          <a:prstGeom prst="straightConnector1">
-            <a:avLst/>
-          </a:prstGeom>
-          <a:ln>
-            <a:tailEnd type="triangle"/>
-          </a:ln>
-        </p:spPr>
-        <p:style>
-          <a:lnRef idx="2">
-            <a:schemeClr val="accent1"/>
-          </a:lnRef>
-          <a:fillRef idx="0">
-            <a:schemeClr val="accent1"/>
-          </a:fillRef>
-          <a:effectRef idx="1">
-            <a:schemeClr val="accent1"/>
-          </a:effectRef>
-          <a:fontRef idx="minor">
-            <a:schemeClr val="tx1"/>
-          </a:fontRef>
-        </p:style>
-      </p:cxnSp>
-      <p:sp>
-        <p:nvSpPr>
-          <p:cNvPr id="26" name="TextBox 25">
-            <a:extLst>
-              <a:ext uri="{FF2B5EF4-FFF2-40B4-BE49-F238E27FC236}">
-                <a16:creationId xmlns:a16="http://schemas.microsoft.com/office/drawing/2014/main" id="{ED699248-9CFD-F064-BF65-9BEB5CF49D1C}"/>
-              </a:ext>
-            </a:extLst>
-          </p:cNvPr>
-          <p:cNvSpPr txBox="1"/>
-          <p:nvPr/>
-        </p:nvSpPr>
-        <p:spPr>
-          <a:xfrm>
-            <a:off x="10259568" y="1271016"/>
-            <a:ext cx="1243584" cy="646331"/>
-          </a:xfrm>
-          <a:prstGeom prst="rect">
-            <a:avLst/>
-          </a:prstGeom>
-          <a:noFill/>
-        </p:spPr>
-        <p:txBody>
-          <a:bodyPr wrap="square" rtlCol="0">
-            <a:spAutoFit/>
-          </a:bodyPr>
-          <a:lstStyle/>
-          <a:p>
-            <a:r>
-              <a:rPr lang="en-GB" sz="1200" dirty="0"/>
-              <a:t>Span is the html that contains email text</a:t>
-            </a:r>
-          </a:p>
-        </p:txBody>
-      </p:sp>
-      <p:sp>
-        <p:nvSpPr>
-          <p:cNvPr id="27" name="Rectangle 26">
-            <a:extLst>
-              <a:ext uri="{FF2B5EF4-FFF2-40B4-BE49-F238E27FC236}">
-                <a16:creationId xmlns:a16="http://schemas.microsoft.com/office/drawing/2014/main" id="{3DD8C56D-6F30-104C-0AC2-1A3CC42CF1C3}"/>
-              </a:ext>
-            </a:extLst>
-          </p:cNvPr>
-          <p:cNvSpPr/>
-          <p:nvPr/>
-        </p:nvSpPr>
-        <p:spPr>
-          <a:xfrm>
-            <a:off x="786384" y="1313610"/>
-            <a:ext cx="1664208" cy="646331"/>
-          </a:xfrm>
-          <a:prstGeom prst="rect">
-            <a:avLst/>
-          </a:prstGeom>
-        </p:spPr>
-        <p:style>
-          <a:lnRef idx="2">
-            <a:schemeClr val="accent1">
-              <a:shade val="15000"/>
-            </a:schemeClr>
-          </a:lnRef>
-          <a:fillRef idx="1">
-            <a:schemeClr val="accent1"/>
-          </a:fillRef>
-          <a:effectRef idx="0">
-            <a:schemeClr val="accent1"/>
-          </a:effectRef>
-          <a:fontRef idx="minor">
-            <a:schemeClr val="lt1"/>
-          </a:fontRef>
-        </p:style>
-        <p:txBody>
-          <a:bodyPr rtlCol="0" anchor="ctr"/>
-          <a:lstStyle/>
-          <a:p>
-            <a:pPr algn="ctr"/>
-            <a:r>
-              <a:rPr lang="en-GB" dirty="0"/>
-              <a:t>HREF</a:t>
+              <a:t>Identify all HREF</a:t>
             </a:r>
           </a:p>
         </p:txBody>
@@ -6274,8 +5968,8 @@
         </p:nvCxnSpPr>
         <p:spPr>
           <a:xfrm flipH="1">
-            <a:off x="2450592" y="1636776"/>
-            <a:ext cx="1645920" cy="0"/>
+            <a:off x="2523744" y="1870198"/>
+            <a:ext cx="1572768" cy="10146"/>
           </a:xfrm>
           <a:prstGeom prst="straightConnector1">
             <a:avLst/>
@@ -6299,26 +5993,141 @@
           </a:fontRef>
         </p:style>
       </p:cxnSp>
+      <p:sp>
+        <p:nvSpPr>
+          <p:cNvPr id="40" name="TextBox 39">
+            <a:extLst>
+              <a:ext uri="{FF2B5EF4-FFF2-40B4-BE49-F238E27FC236}">
+                <a16:creationId xmlns:a16="http://schemas.microsoft.com/office/drawing/2014/main" id="{7510B607-9170-BA74-C912-F3E760208681}"/>
+              </a:ext>
+            </a:extLst>
+          </p:cNvPr>
+          <p:cNvSpPr txBox="1"/>
+          <p:nvPr/>
+        </p:nvSpPr>
+        <p:spPr>
+          <a:xfrm>
+            <a:off x="1371600" y="1272515"/>
+            <a:ext cx="1152144" cy="307777"/>
+          </a:xfrm>
+          <a:prstGeom prst="rect">
+            <a:avLst/>
+          </a:prstGeom>
+          <a:noFill/>
+        </p:spPr>
+        <p:txBody>
+          <a:bodyPr wrap="square" rtlCol="0">
+            <a:spAutoFit/>
+          </a:bodyPr>
+          <a:lstStyle/>
+          <a:p>
+            <a:r>
+              <a:rPr lang="en-GB" sz="1400" dirty="0"/>
+              <a:t>*Links</a:t>
+            </a:r>
+          </a:p>
+        </p:txBody>
+      </p:sp>
+      <p:sp>
+        <p:nvSpPr>
+          <p:cNvPr id="41" name="TextBox 40">
+            <a:extLst>
+              <a:ext uri="{FF2B5EF4-FFF2-40B4-BE49-F238E27FC236}">
+                <a16:creationId xmlns:a16="http://schemas.microsoft.com/office/drawing/2014/main" id="{A28CDCA3-B7E9-2AE9-2B35-586EC4C56BA6}"/>
+              </a:ext>
+            </a:extLst>
+          </p:cNvPr>
+          <p:cNvSpPr txBox="1"/>
+          <p:nvPr/>
+        </p:nvSpPr>
+        <p:spPr>
+          <a:xfrm>
+            <a:off x="7095744" y="2644175"/>
+            <a:ext cx="1356360" cy="307777"/>
+          </a:xfrm>
+          <a:prstGeom prst="rect">
+            <a:avLst/>
+          </a:prstGeom>
+          <a:noFill/>
+        </p:spPr>
+        <p:txBody>
+          <a:bodyPr wrap="square" rtlCol="0">
+            <a:spAutoFit/>
+          </a:bodyPr>
+          <a:lstStyle/>
+          <a:p>
+            <a:endParaRPr lang="en-GB" sz="1400" dirty="0"/>
+          </a:p>
+        </p:txBody>
+      </p:sp>
+      <p:sp>
+        <p:nvSpPr>
+          <p:cNvPr id="5" name="Rectangle 4">
+            <a:extLst>
+              <a:ext uri="{FF2B5EF4-FFF2-40B4-BE49-F238E27FC236}">
+                <a16:creationId xmlns:a16="http://schemas.microsoft.com/office/drawing/2014/main" id="{F9C75174-9808-0D34-CCC6-D369213246EE}"/>
+              </a:ext>
+            </a:extLst>
+          </p:cNvPr>
+          <p:cNvSpPr/>
+          <p:nvPr/>
+        </p:nvSpPr>
+        <p:spPr>
+          <a:xfrm>
+            <a:off x="4346448" y="54083"/>
+            <a:ext cx="1694688" cy="716801"/>
+          </a:xfrm>
+          <a:prstGeom prst="rect">
+            <a:avLst/>
+          </a:prstGeom>
+        </p:spPr>
+        <p:style>
+          <a:lnRef idx="2">
+            <a:schemeClr val="accent1">
+              <a:shade val="15000"/>
+            </a:schemeClr>
+          </a:lnRef>
+          <a:fillRef idx="1">
+            <a:schemeClr val="accent1"/>
+          </a:fillRef>
+          <a:effectRef idx="0">
+            <a:schemeClr val="accent1"/>
+          </a:effectRef>
+          <a:fontRef idx="minor">
+            <a:schemeClr val="lt1"/>
+          </a:fontRef>
+        </p:style>
+        <p:txBody>
+          <a:bodyPr rtlCol="0" anchor="ctr"/>
+          <a:lstStyle/>
+          <a:p>
+            <a:pPr algn="ctr"/>
+            <a:r>
+              <a:rPr lang="en-GB" dirty="0"/>
+              <a:t>Start </a:t>
+            </a:r>
+          </a:p>
+        </p:txBody>
+      </p:sp>
       <p:cxnSp>
         <p:nvCxnSpPr>
-          <p:cNvPr id="34" name="Straight Arrow Connector 33">
-            <a:extLst>
-              <a:ext uri="{FF2B5EF4-FFF2-40B4-BE49-F238E27FC236}">
-                <a16:creationId xmlns:a16="http://schemas.microsoft.com/office/drawing/2014/main" id="{25148B76-9562-B2A0-BC13-BDAEDF4189B1}"/>
+          <p:cNvPr id="10" name="Straight Arrow Connector 9">
+            <a:extLst>
+              <a:ext uri="{FF2B5EF4-FFF2-40B4-BE49-F238E27FC236}">
+                <a16:creationId xmlns:a16="http://schemas.microsoft.com/office/drawing/2014/main" id="{3AC244E7-8FE8-5967-7F62-2C02297D2BCD}"/>
               </a:ext>
             </a:extLst>
           </p:cNvPr>
           <p:cNvCxnSpPr>
-            <a:cxnSpLocks/>
-            <a:stCxn id="27" idx="2"/>
-            <a:endCxn id="17" idx="0"/>
+            <a:stCxn id="5" idx="2"/>
+            <a:endCxn id="3" idx="0"/>
           </p:cNvCxnSpPr>
           <p:nvPr/>
         </p:nvCxnSpPr>
         <p:spPr>
           <a:xfrm>
-            <a:off x="1618488" y="1959941"/>
-            <a:ext cx="0" cy="1633651"/>
+            <a:off x="5193792" y="770884"/>
+            <a:ext cx="0" cy="733554"/>
           </a:xfrm>
           <a:prstGeom prst="straightConnector1">
             <a:avLst/>
@@ -6344,119 +6153,2543 @@
       </p:cxnSp>
       <p:sp>
         <p:nvSpPr>
-          <p:cNvPr id="40" name="TextBox 39">
-            <a:extLst>
-              <a:ext uri="{FF2B5EF4-FFF2-40B4-BE49-F238E27FC236}">
-                <a16:creationId xmlns:a16="http://schemas.microsoft.com/office/drawing/2014/main" id="{7510B607-9170-BA74-C912-F3E760208681}"/>
-              </a:ext>
-            </a:extLst>
-          </p:cNvPr>
-          <p:cNvSpPr txBox="1"/>
-          <p:nvPr/>
-        </p:nvSpPr>
-        <p:spPr>
-          <a:xfrm>
-            <a:off x="1298448" y="960120"/>
-            <a:ext cx="1152144" cy="307777"/>
+          <p:cNvPr id="12" name="Rectangle 11">
+            <a:extLst>
+              <a:ext uri="{FF2B5EF4-FFF2-40B4-BE49-F238E27FC236}">
+                <a16:creationId xmlns:a16="http://schemas.microsoft.com/office/drawing/2014/main" id="{7904B4D2-6E6F-4459-B3B1-0D998CAC99E6}"/>
+              </a:ext>
+            </a:extLst>
+          </p:cNvPr>
+          <p:cNvSpPr/>
+          <p:nvPr/>
+        </p:nvSpPr>
+        <p:spPr>
+          <a:xfrm>
+            <a:off x="786384" y="2946871"/>
+            <a:ext cx="1810512" cy="634952"/>
           </a:xfrm>
           <a:prstGeom prst="rect">
             <a:avLst/>
           </a:prstGeom>
-          <a:noFill/>
-        </p:spPr>
-        <p:txBody>
-          <a:bodyPr wrap="square" rtlCol="0">
-            <a:spAutoFit/>
-          </a:bodyPr>
-          <a:lstStyle/>
-          <a:p>
-            <a:r>
-              <a:rPr lang="en-GB" sz="1400" dirty="0" err="1"/>
-              <a:t>HyperLink</a:t>
-            </a:r>
-            <a:endParaRPr lang="en-GB" sz="1400" dirty="0"/>
-          </a:p>
-        </p:txBody>
-      </p:sp>
-      <p:sp>
-        <p:nvSpPr>
-          <p:cNvPr id="41" name="TextBox 40">
-            <a:extLst>
-              <a:ext uri="{FF2B5EF4-FFF2-40B4-BE49-F238E27FC236}">
-                <a16:creationId xmlns:a16="http://schemas.microsoft.com/office/drawing/2014/main" id="{A28CDCA3-B7E9-2AE9-2B35-586EC4C56BA6}"/>
-              </a:ext>
-            </a:extLst>
-          </p:cNvPr>
-          <p:cNvSpPr txBox="1"/>
-          <p:nvPr/>
-        </p:nvSpPr>
-        <p:spPr>
-          <a:xfrm>
-            <a:off x="6461760" y="3698749"/>
-            <a:ext cx="1356360" cy="307777"/>
+        </p:spPr>
+        <p:style>
+          <a:lnRef idx="2">
+            <a:schemeClr val="accent1">
+              <a:shade val="15000"/>
+            </a:schemeClr>
+          </a:lnRef>
+          <a:fillRef idx="1">
+            <a:schemeClr val="accent1"/>
+          </a:fillRef>
+          <a:effectRef idx="0">
+            <a:schemeClr val="accent1"/>
+          </a:effectRef>
+          <a:fontRef idx="minor">
+            <a:schemeClr val="lt1"/>
+          </a:fontRef>
+        </p:style>
+        <p:txBody>
+          <a:bodyPr rtlCol="0" anchor="ctr"/>
+          <a:lstStyle/>
+          <a:p>
+            <a:pPr algn="ctr"/>
+            <a:r>
+              <a:rPr lang="en-GB" dirty="0"/>
+              <a:t>Run link scan</a:t>
+            </a:r>
+          </a:p>
+        </p:txBody>
+      </p:sp>
+      <p:cxnSp>
+        <p:nvCxnSpPr>
+          <p:cNvPr id="15" name="Straight Arrow Connector 14">
+            <a:extLst>
+              <a:ext uri="{FF2B5EF4-FFF2-40B4-BE49-F238E27FC236}">
+                <a16:creationId xmlns:a16="http://schemas.microsoft.com/office/drawing/2014/main" id="{E08942ED-ED67-35EF-691D-54E398394158}"/>
+              </a:ext>
+            </a:extLst>
+          </p:cNvPr>
+          <p:cNvCxnSpPr>
+            <a:stCxn id="27" idx="2"/>
+            <a:endCxn id="12" idx="0"/>
+          </p:cNvCxnSpPr>
+          <p:nvPr/>
+        </p:nvCxnSpPr>
+        <p:spPr>
+          <a:xfrm>
+            <a:off x="1691640" y="2203509"/>
+            <a:ext cx="0" cy="743362"/>
+          </a:xfrm>
+          <a:prstGeom prst="straightConnector1">
+            <a:avLst/>
+          </a:prstGeom>
+          <a:ln>
+            <a:tailEnd type="triangle"/>
+          </a:ln>
+        </p:spPr>
+        <p:style>
+          <a:lnRef idx="2">
+            <a:schemeClr val="accent1"/>
+          </a:lnRef>
+          <a:fillRef idx="0">
+            <a:schemeClr val="accent1"/>
+          </a:fillRef>
+          <a:effectRef idx="1">
+            <a:schemeClr val="accent1"/>
+          </a:effectRef>
+          <a:fontRef idx="minor">
+            <a:schemeClr val="tx1"/>
+          </a:fontRef>
+        </p:style>
+      </p:cxnSp>
+      <p:sp>
+        <p:nvSpPr>
+          <p:cNvPr id="20" name="Rectangle 19">
+            <a:extLst>
+              <a:ext uri="{FF2B5EF4-FFF2-40B4-BE49-F238E27FC236}">
+                <a16:creationId xmlns:a16="http://schemas.microsoft.com/office/drawing/2014/main" id="{FF6CDCCE-B03D-75BB-31B3-BAE5F17CCAC0}"/>
+              </a:ext>
+            </a:extLst>
+          </p:cNvPr>
+          <p:cNvSpPr/>
+          <p:nvPr/>
+        </p:nvSpPr>
+        <p:spPr>
+          <a:xfrm>
+            <a:off x="7936992" y="2946871"/>
+            <a:ext cx="2194560" cy="805677"/>
           </a:xfrm>
           <a:prstGeom prst="rect">
             <a:avLst/>
           </a:prstGeom>
-          <a:noFill/>
-        </p:spPr>
-        <p:txBody>
-          <a:bodyPr wrap="square" rtlCol="0">
-            <a:spAutoFit/>
-          </a:bodyPr>
-          <a:lstStyle/>
-          <a:p>
-            <a:r>
-              <a:rPr lang="en-GB" sz="1400" dirty="0"/>
-              <a:t>Isolate the</a:t>
-            </a:r>
-          </a:p>
-        </p:txBody>
-      </p:sp>
-      <p:sp>
-        <p:nvSpPr>
-          <p:cNvPr id="42" name="TextBox 41">
-            <a:extLst>
-              <a:ext uri="{FF2B5EF4-FFF2-40B4-BE49-F238E27FC236}">
-                <a16:creationId xmlns:a16="http://schemas.microsoft.com/office/drawing/2014/main" id="{BACFE7CE-37E7-2A49-EA84-DE6EF7E3C7FF}"/>
-              </a:ext>
-            </a:extLst>
-          </p:cNvPr>
-          <p:cNvSpPr txBox="1"/>
-          <p:nvPr/>
-        </p:nvSpPr>
-        <p:spPr>
-          <a:xfrm>
-            <a:off x="2990088" y="3591027"/>
-            <a:ext cx="1243584" cy="523220"/>
+        </p:spPr>
+        <p:style>
+          <a:lnRef idx="2">
+            <a:schemeClr val="accent1">
+              <a:shade val="15000"/>
+            </a:schemeClr>
+          </a:lnRef>
+          <a:fillRef idx="1">
+            <a:schemeClr val="accent1"/>
+          </a:fillRef>
+          <a:effectRef idx="0">
+            <a:schemeClr val="accent1"/>
+          </a:effectRef>
+          <a:fontRef idx="minor">
+            <a:schemeClr val="lt1"/>
+          </a:fontRef>
+        </p:style>
+        <p:txBody>
+          <a:bodyPr rtlCol="0" anchor="ctr"/>
+          <a:lstStyle/>
+          <a:p>
+            <a:pPr algn="ctr"/>
+            <a:r>
+              <a:rPr lang="en-GB" dirty="0"/>
+              <a:t>Run Bad Words Scan</a:t>
+            </a:r>
+          </a:p>
+        </p:txBody>
+      </p:sp>
+      <p:cxnSp>
+        <p:nvCxnSpPr>
+          <p:cNvPr id="22" name="Straight Arrow Connector 21">
+            <a:extLst>
+              <a:ext uri="{FF2B5EF4-FFF2-40B4-BE49-F238E27FC236}">
+                <a16:creationId xmlns:a16="http://schemas.microsoft.com/office/drawing/2014/main" id="{F61711E5-7FEA-FE3F-70BB-B4483029AC50}"/>
+              </a:ext>
+            </a:extLst>
+          </p:cNvPr>
+          <p:cNvCxnSpPr>
+            <a:stCxn id="4" idx="2"/>
+            <a:endCxn id="20" idx="0"/>
+          </p:cNvCxnSpPr>
+          <p:nvPr/>
+        </p:nvCxnSpPr>
+        <p:spPr>
+          <a:xfrm flipH="1">
+            <a:off x="9034272" y="2161493"/>
+            <a:ext cx="3048" cy="785378"/>
+          </a:xfrm>
+          <a:prstGeom prst="straightConnector1">
+            <a:avLst/>
+          </a:prstGeom>
+          <a:ln>
+            <a:tailEnd type="triangle"/>
+          </a:ln>
+        </p:spPr>
+        <p:style>
+          <a:lnRef idx="2">
+            <a:schemeClr val="accent1"/>
+          </a:lnRef>
+          <a:fillRef idx="0">
+            <a:schemeClr val="accent1"/>
+          </a:fillRef>
+          <a:effectRef idx="1">
+            <a:schemeClr val="accent1"/>
+          </a:effectRef>
+          <a:fontRef idx="minor">
+            <a:schemeClr val="tx1"/>
+          </a:fontRef>
+        </p:style>
+      </p:cxnSp>
+      <p:sp>
+        <p:nvSpPr>
+          <p:cNvPr id="23" name="Rectangle 22">
+            <a:extLst>
+              <a:ext uri="{FF2B5EF4-FFF2-40B4-BE49-F238E27FC236}">
+                <a16:creationId xmlns:a16="http://schemas.microsoft.com/office/drawing/2014/main" id="{85E5E111-BF36-D91D-13AE-FC77EEF156D1}"/>
+              </a:ext>
+            </a:extLst>
+          </p:cNvPr>
+          <p:cNvSpPr/>
+          <p:nvPr/>
+        </p:nvSpPr>
+        <p:spPr>
+          <a:xfrm>
+            <a:off x="4096512" y="2798063"/>
+            <a:ext cx="2194560" cy="1103293"/>
           </a:xfrm>
           <a:prstGeom prst="rect">
             <a:avLst/>
           </a:prstGeom>
-          <a:noFill/>
-        </p:spPr>
-        <p:txBody>
-          <a:bodyPr wrap="square" rtlCol="0">
-            <a:spAutoFit/>
-          </a:bodyPr>
-          <a:lstStyle/>
-          <a:p>
-            <a:r>
-              <a:rPr lang="en-GB" sz="1400" dirty="0"/>
-              <a:t>Modify its html/</a:t>
-            </a:r>
-            <a:r>
-              <a:rPr lang="en-GB" sz="1400" dirty="0" err="1"/>
-              <a:t>css</a:t>
-            </a:r>
-            <a:endParaRPr lang="en-GB" sz="1400" dirty="0"/>
-          </a:p>
-        </p:txBody>
-      </p:sp>
+        </p:spPr>
+        <p:style>
+          <a:lnRef idx="2">
+            <a:schemeClr val="accent1">
+              <a:shade val="15000"/>
+            </a:schemeClr>
+          </a:lnRef>
+          <a:fillRef idx="1">
+            <a:schemeClr val="accent1"/>
+          </a:fillRef>
+          <a:effectRef idx="0">
+            <a:schemeClr val="accent1"/>
+          </a:effectRef>
+          <a:fontRef idx="minor">
+            <a:schemeClr val="lt1"/>
+          </a:fontRef>
+        </p:style>
+        <p:txBody>
+          <a:bodyPr rtlCol="0" anchor="ctr"/>
+          <a:lstStyle/>
+          <a:p>
+            <a:pPr algn="ctr"/>
+            <a:r>
+              <a:rPr lang="en-GB" dirty="0"/>
+              <a:t>Isolate from body Add Listeners, attach data and inject custom CSS</a:t>
+            </a:r>
+          </a:p>
+        </p:txBody>
+      </p:sp>
+      <p:cxnSp>
+        <p:nvCxnSpPr>
+          <p:cNvPr id="25" name="Straight Arrow Connector 24">
+            <a:extLst>
+              <a:ext uri="{FF2B5EF4-FFF2-40B4-BE49-F238E27FC236}">
+                <a16:creationId xmlns:a16="http://schemas.microsoft.com/office/drawing/2014/main" id="{B0C95A2E-AE2D-FC73-C702-C6116BB834DC}"/>
+              </a:ext>
+            </a:extLst>
+          </p:cNvPr>
+          <p:cNvCxnSpPr>
+            <a:cxnSpLocks/>
+            <a:stCxn id="12" idx="3"/>
+            <a:endCxn id="23" idx="1"/>
+          </p:cNvCxnSpPr>
+          <p:nvPr/>
+        </p:nvCxnSpPr>
+        <p:spPr>
+          <a:xfrm>
+            <a:off x="2596896" y="3264347"/>
+            <a:ext cx="1499616" cy="85363"/>
+          </a:xfrm>
+          <a:prstGeom prst="straightConnector1">
+            <a:avLst/>
+          </a:prstGeom>
+          <a:ln>
+            <a:tailEnd type="triangle"/>
+          </a:ln>
+        </p:spPr>
+        <p:style>
+          <a:lnRef idx="2">
+            <a:schemeClr val="accent1"/>
+          </a:lnRef>
+          <a:fillRef idx="0">
+            <a:schemeClr val="accent1"/>
+          </a:fillRef>
+          <a:effectRef idx="1">
+            <a:schemeClr val="accent1"/>
+          </a:effectRef>
+          <a:fontRef idx="minor">
+            <a:schemeClr val="tx1"/>
+          </a:fontRef>
+        </p:style>
+      </p:cxnSp>
+      <p:cxnSp>
+        <p:nvCxnSpPr>
+          <p:cNvPr id="30" name="Straight Arrow Connector 29">
+            <a:extLst>
+              <a:ext uri="{FF2B5EF4-FFF2-40B4-BE49-F238E27FC236}">
+                <a16:creationId xmlns:a16="http://schemas.microsoft.com/office/drawing/2014/main" id="{78EA51C7-3C4E-CF89-DAFE-BFE5FC6D0E2B}"/>
+              </a:ext>
+            </a:extLst>
+          </p:cNvPr>
+          <p:cNvCxnSpPr>
+            <a:cxnSpLocks/>
+            <a:stCxn id="20" idx="1"/>
+            <a:endCxn id="23" idx="3"/>
+          </p:cNvCxnSpPr>
+          <p:nvPr/>
+        </p:nvCxnSpPr>
+        <p:spPr>
+          <a:xfrm flipH="1">
+            <a:off x="6291072" y="3349710"/>
+            <a:ext cx="1645920" cy="0"/>
+          </a:xfrm>
+          <a:prstGeom prst="straightConnector1">
+            <a:avLst/>
+          </a:prstGeom>
+          <a:ln>
+            <a:tailEnd type="triangle"/>
+          </a:ln>
+        </p:spPr>
+        <p:style>
+          <a:lnRef idx="2">
+            <a:schemeClr val="accent1"/>
+          </a:lnRef>
+          <a:fillRef idx="0">
+            <a:schemeClr val="accent1"/>
+          </a:fillRef>
+          <a:effectRef idx="1">
+            <a:schemeClr val="accent1"/>
+          </a:effectRef>
+          <a:fontRef idx="minor">
+            <a:schemeClr val="tx1"/>
+          </a:fontRef>
+        </p:style>
+      </p:cxnSp>
+      <p:sp>
+        <p:nvSpPr>
+          <p:cNvPr id="36" name="Rectangle 35">
+            <a:extLst>
+              <a:ext uri="{FF2B5EF4-FFF2-40B4-BE49-F238E27FC236}">
+                <a16:creationId xmlns:a16="http://schemas.microsoft.com/office/drawing/2014/main" id="{D16D9DF0-3758-50E2-BDEC-424FAE41A8DD}"/>
+              </a:ext>
+            </a:extLst>
+          </p:cNvPr>
+          <p:cNvSpPr/>
+          <p:nvPr/>
+        </p:nvSpPr>
+        <p:spPr>
+          <a:xfrm>
+            <a:off x="4169664" y="4547699"/>
+            <a:ext cx="2048256" cy="1103293"/>
+          </a:xfrm>
+          <a:prstGeom prst="rect">
+            <a:avLst/>
+          </a:prstGeom>
+        </p:spPr>
+        <p:style>
+          <a:lnRef idx="2">
+            <a:schemeClr val="accent1">
+              <a:shade val="15000"/>
+            </a:schemeClr>
+          </a:lnRef>
+          <a:fillRef idx="1">
+            <a:schemeClr val="accent1"/>
+          </a:fillRef>
+          <a:effectRef idx="0">
+            <a:schemeClr val="accent1"/>
+          </a:effectRef>
+          <a:fontRef idx="minor">
+            <a:schemeClr val="lt1"/>
+          </a:fontRef>
+        </p:style>
+        <p:txBody>
+          <a:bodyPr rtlCol="0" anchor="ctr"/>
+          <a:lstStyle/>
+          <a:p>
+            <a:pPr algn="ctr"/>
+            <a:r>
+              <a:rPr lang="en-GB" dirty="0"/>
+              <a:t>On Hover Display data for specific item</a:t>
+            </a:r>
+          </a:p>
+        </p:txBody>
+      </p:sp>
+      <p:cxnSp>
+        <p:nvCxnSpPr>
+          <p:cNvPr id="38" name="Straight Arrow Connector 37">
+            <a:extLst>
+              <a:ext uri="{FF2B5EF4-FFF2-40B4-BE49-F238E27FC236}">
+                <a16:creationId xmlns:a16="http://schemas.microsoft.com/office/drawing/2014/main" id="{DC481E87-D81F-EF50-1191-974D1E369900}"/>
+              </a:ext>
+            </a:extLst>
+          </p:cNvPr>
+          <p:cNvCxnSpPr>
+            <a:stCxn id="23" idx="2"/>
+            <a:endCxn id="36" idx="0"/>
+          </p:cNvCxnSpPr>
+          <p:nvPr/>
+        </p:nvCxnSpPr>
+        <p:spPr>
+          <a:xfrm>
+            <a:off x="5193792" y="3901356"/>
+            <a:ext cx="0" cy="646343"/>
+          </a:xfrm>
+          <a:prstGeom prst="straightConnector1">
+            <a:avLst/>
+          </a:prstGeom>
+          <a:ln>
+            <a:tailEnd type="triangle"/>
+          </a:ln>
+        </p:spPr>
+        <p:style>
+          <a:lnRef idx="2">
+            <a:schemeClr val="accent1"/>
+          </a:lnRef>
+          <a:fillRef idx="0">
+            <a:schemeClr val="accent1"/>
+          </a:fillRef>
+          <a:effectRef idx="1">
+            <a:schemeClr val="accent1"/>
+          </a:effectRef>
+          <a:fontRef idx="minor">
+            <a:schemeClr val="tx1"/>
+          </a:fontRef>
+        </p:style>
+      </p:cxnSp>
     </p:spTree>
     <p:extLst>
       <p:ext uri="{BB962C8B-B14F-4D97-AF65-F5344CB8AC3E}">
         <p14:creationId xmlns:p14="http://schemas.microsoft.com/office/powerpoint/2010/main" val="3827761004"/>
+      </p:ext>
+    </p:extLst>
+  </p:cSld>
+  <p:clrMapOvr>
+    <a:masterClrMapping/>
+  </p:clrMapOvr>
+</p:sld>
+</file>
+
+<file path=ppt/slides/slide4.xml><?xml version="1.0" encoding="utf-8"?>
+<p:sld xmlns:a="http://schemas.openxmlformats.org/drawingml/2006/main" xmlns:r="http://schemas.openxmlformats.org/officeDocument/2006/relationships" xmlns:p="http://schemas.openxmlformats.org/presentationml/2006/main">
+  <p:cSld>
+    <p:spTree>
+      <p:nvGrpSpPr>
+        <p:cNvPr id="1" name=""/>
+        <p:cNvGrpSpPr/>
+        <p:nvPr/>
+      </p:nvGrpSpPr>
+      <p:grpSpPr>
+        <a:xfrm>
+          <a:off x="0" y="0"/>
+          <a:ext cx="0" cy="0"/>
+          <a:chOff x="0" y="0"/>
+          <a:chExt cx="0" cy="0"/>
+        </a:xfrm>
+      </p:grpSpPr>
+      <p:sp>
+        <p:nvSpPr>
+          <p:cNvPr id="4" name="Rectangle 3">
+            <a:extLst>
+              <a:ext uri="{FF2B5EF4-FFF2-40B4-BE49-F238E27FC236}">
+                <a16:creationId xmlns:a16="http://schemas.microsoft.com/office/drawing/2014/main" id="{21799347-400D-BAD2-0986-EF232DB30FA9}"/>
+              </a:ext>
+            </a:extLst>
+          </p:cNvPr>
+          <p:cNvSpPr/>
+          <p:nvPr/>
+        </p:nvSpPr>
+        <p:spPr>
+          <a:xfrm>
+            <a:off x="0" y="0"/>
+            <a:ext cx="2331720" cy="813816"/>
+          </a:xfrm>
+          <a:prstGeom prst="rect">
+            <a:avLst/>
+          </a:prstGeom>
+        </p:spPr>
+        <p:style>
+          <a:lnRef idx="2">
+            <a:schemeClr val="accent1">
+              <a:shade val="15000"/>
+            </a:schemeClr>
+          </a:lnRef>
+          <a:fillRef idx="1">
+            <a:schemeClr val="accent1"/>
+          </a:fillRef>
+          <a:effectRef idx="0">
+            <a:schemeClr val="accent1"/>
+          </a:effectRef>
+          <a:fontRef idx="minor">
+            <a:schemeClr val="lt1"/>
+          </a:fontRef>
+        </p:style>
+        <p:txBody>
+          <a:bodyPr rtlCol="0" anchor="ctr"/>
+          <a:lstStyle/>
+          <a:p>
+            <a:pPr algn="ctr"/>
+            <a:r>
+              <a:rPr lang="en-GB" dirty="0"/>
+              <a:t>UR risk analysis API web v1</a:t>
+            </a:r>
+          </a:p>
+        </p:txBody>
+      </p:sp>
+      <p:sp>
+        <p:nvSpPr>
+          <p:cNvPr id="5" name="Rectangle 4">
+            <a:extLst>
+              <a:ext uri="{FF2B5EF4-FFF2-40B4-BE49-F238E27FC236}">
+                <a16:creationId xmlns:a16="http://schemas.microsoft.com/office/drawing/2014/main" id="{9E681D00-77F4-68D5-A1D1-8C6945C4D29C}"/>
+              </a:ext>
+            </a:extLst>
+          </p:cNvPr>
+          <p:cNvSpPr/>
+          <p:nvPr/>
+        </p:nvSpPr>
+        <p:spPr>
+          <a:xfrm>
+            <a:off x="3651504" y="96012"/>
+            <a:ext cx="1837944" cy="740664"/>
+          </a:xfrm>
+          <a:prstGeom prst="rect">
+            <a:avLst/>
+          </a:prstGeom>
+        </p:spPr>
+        <p:style>
+          <a:lnRef idx="2">
+            <a:schemeClr val="accent1">
+              <a:shade val="15000"/>
+            </a:schemeClr>
+          </a:lnRef>
+          <a:fillRef idx="1">
+            <a:schemeClr val="accent1"/>
+          </a:fillRef>
+          <a:effectRef idx="0">
+            <a:schemeClr val="accent1"/>
+          </a:effectRef>
+          <a:fontRef idx="minor">
+            <a:schemeClr val="lt1"/>
+          </a:fontRef>
+        </p:style>
+        <p:txBody>
+          <a:bodyPr rtlCol="0" anchor="ctr"/>
+          <a:lstStyle/>
+          <a:p>
+            <a:pPr algn="ctr"/>
+            <a:r>
+              <a:rPr lang="en-GB" dirty="0"/>
+              <a:t>URLS identified</a:t>
+            </a:r>
+          </a:p>
+        </p:txBody>
+      </p:sp>
+      <p:sp>
+        <p:nvSpPr>
+          <p:cNvPr id="6" name="Rectangle 5">
+            <a:extLst>
+              <a:ext uri="{FF2B5EF4-FFF2-40B4-BE49-F238E27FC236}">
+                <a16:creationId xmlns:a16="http://schemas.microsoft.com/office/drawing/2014/main" id="{2AA2D753-79B5-5C96-4D99-30754DE14177}"/>
+              </a:ext>
+            </a:extLst>
+          </p:cNvPr>
+          <p:cNvSpPr/>
+          <p:nvPr/>
+        </p:nvSpPr>
+        <p:spPr>
+          <a:xfrm>
+            <a:off x="2153791" y="3607308"/>
+            <a:ext cx="1752600" cy="740664"/>
+          </a:xfrm>
+          <a:prstGeom prst="rect">
+            <a:avLst/>
+          </a:prstGeom>
+        </p:spPr>
+        <p:style>
+          <a:lnRef idx="2">
+            <a:schemeClr val="accent1">
+              <a:shade val="15000"/>
+            </a:schemeClr>
+          </a:lnRef>
+          <a:fillRef idx="1">
+            <a:schemeClr val="accent1"/>
+          </a:fillRef>
+          <a:effectRef idx="0">
+            <a:schemeClr val="accent1"/>
+          </a:effectRef>
+          <a:fontRef idx="minor">
+            <a:schemeClr val="lt1"/>
+          </a:fontRef>
+        </p:style>
+        <p:txBody>
+          <a:bodyPr rtlCol="0" anchor="ctr"/>
+          <a:lstStyle/>
+          <a:p>
+            <a:pPr algn="ctr"/>
+            <a:r>
+              <a:rPr lang="en-GB" dirty="0"/>
+              <a:t>Perform</a:t>
+            </a:r>
+          </a:p>
+          <a:p>
+            <a:pPr algn="ctr"/>
+            <a:r>
+              <a:rPr lang="en-GB" dirty="0"/>
+              <a:t>WHOIS API call</a:t>
+            </a:r>
+          </a:p>
+        </p:txBody>
+      </p:sp>
+      <p:sp>
+        <p:nvSpPr>
+          <p:cNvPr id="7" name="Rectangle 6">
+            <a:extLst>
+              <a:ext uri="{FF2B5EF4-FFF2-40B4-BE49-F238E27FC236}">
+                <a16:creationId xmlns:a16="http://schemas.microsoft.com/office/drawing/2014/main" id="{B7DECB14-6CBE-0613-E54B-DDE451DE05A6}"/>
+              </a:ext>
+            </a:extLst>
+          </p:cNvPr>
+          <p:cNvSpPr/>
+          <p:nvPr/>
+        </p:nvSpPr>
+        <p:spPr>
+          <a:xfrm>
+            <a:off x="3672840" y="2350008"/>
+            <a:ext cx="1795272" cy="621792"/>
+          </a:xfrm>
+          <a:prstGeom prst="rect">
+            <a:avLst/>
+          </a:prstGeom>
+        </p:spPr>
+        <p:style>
+          <a:lnRef idx="2">
+            <a:schemeClr val="accent1">
+              <a:shade val="15000"/>
+            </a:schemeClr>
+          </a:lnRef>
+          <a:fillRef idx="1">
+            <a:schemeClr val="accent1"/>
+          </a:fillRef>
+          <a:effectRef idx="0">
+            <a:schemeClr val="accent1"/>
+          </a:effectRef>
+          <a:fontRef idx="minor">
+            <a:schemeClr val="lt1"/>
+          </a:fontRef>
+        </p:style>
+        <p:txBody>
+          <a:bodyPr rtlCol="0" anchor="ctr"/>
+          <a:lstStyle/>
+          <a:p>
+            <a:pPr algn="ctr"/>
+            <a:r>
+              <a:rPr lang="en-GB" dirty="0"/>
+              <a:t>Normalise URL</a:t>
+            </a:r>
+          </a:p>
+        </p:txBody>
+      </p:sp>
+      <p:cxnSp>
+        <p:nvCxnSpPr>
+          <p:cNvPr id="9" name="Straight Arrow Connector 8">
+            <a:extLst>
+              <a:ext uri="{FF2B5EF4-FFF2-40B4-BE49-F238E27FC236}">
+                <a16:creationId xmlns:a16="http://schemas.microsoft.com/office/drawing/2014/main" id="{647819EA-3D84-7A61-AD91-9251A4059B90}"/>
+              </a:ext>
+            </a:extLst>
+          </p:cNvPr>
+          <p:cNvCxnSpPr>
+            <a:stCxn id="7" idx="2"/>
+            <a:endCxn id="6" idx="0"/>
+          </p:cNvCxnSpPr>
+          <p:nvPr/>
+        </p:nvCxnSpPr>
+        <p:spPr>
+          <a:xfrm flipH="1">
+            <a:off x="3030091" y="2971800"/>
+            <a:ext cx="1540385" cy="635508"/>
+          </a:xfrm>
+          <a:prstGeom prst="straightConnector1">
+            <a:avLst/>
+          </a:prstGeom>
+          <a:ln>
+            <a:tailEnd type="triangle"/>
+          </a:ln>
+        </p:spPr>
+        <p:style>
+          <a:lnRef idx="2">
+            <a:schemeClr val="accent1"/>
+          </a:lnRef>
+          <a:fillRef idx="0">
+            <a:schemeClr val="accent1"/>
+          </a:fillRef>
+          <a:effectRef idx="1">
+            <a:schemeClr val="accent1"/>
+          </a:effectRef>
+          <a:fontRef idx="minor">
+            <a:schemeClr val="tx1"/>
+          </a:fontRef>
+        </p:style>
+      </p:cxnSp>
+      <p:sp>
+        <p:nvSpPr>
+          <p:cNvPr id="11" name="Rectangle 10">
+            <a:extLst>
+              <a:ext uri="{FF2B5EF4-FFF2-40B4-BE49-F238E27FC236}">
+                <a16:creationId xmlns:a16="http://schemas.microsoft.com/office/drawing/2014/main" id="{E993CFCC-59C4-1746-C3F9-453019687C25}"/>
+              </a:ext>
+            </a:extLst>
+          </p:cNvPr>
+          <p:cNvSpPr/>
+          <p:nvPr/>
+        </p:nvSpPr>
+        <p:spPr>
+          <a:xfrm>
+            <a:off x="4343400" y="3630168"/>
+            <a:ext cx="1752600" cy="740664"/>
+          </a:xfrm>
+          <a:prstGeom prst="rect">
+            <a:avLst/>
+          </a:prstGeom>
+        </p:spPr>
+        <p:style>
+          <a:lnRef idx="2">
+            <a:schemeClr val="accent1">
+              <a:shade val="15000"/>
+            </a:schemeClr>
+          </a:lnRef>
+          <a:fillRef idx="1">
+            <a:schemeClr val="accent1"/>
+          </a:fillRef>
+          <a:effectRef idx="0">
+            <a:schemeClr val="accent1"/>
+          </a:effectRef>
+          <a:fontRef idx="minor">
+            <a:schemeClr val="lt1"/>
+          </a:fontRef>
+        </p:style>
+        <p:txBody>
+          <a:bodyPr rtlCol="0" anchor="ctr"/>
+          <a:lstStyle/>
+          <a:p>
+            <a:pPr algn="ctr"/>
+            <a:r>
+              <a:rPr lang="en-GB" dirty="0"/>
+              <a:t>Perform</a:t>
+            </a:r>
+          </a:p>
+          <a:p>
+            <a:pPr algn="ctr"/>
+            <a:r>
+              <a:rPr lang="en-GB" dirty="0"/>
+              <a:t>VIRUSTOTAL API call</a:t>
+            </a:r>
+          </a:p>
+        </p:txBody>
+      </p:sp>
+      <p:cxnSp>
+        <p:nvCxnSpPr>
+          <p:cNvPr id="13" name="Straight Arrow Connector 12">
+            <a:extLst>
+              <a:ext uri="{FF2B5EF4-FFF2-40B4-BE49-F238E27FC236}">
+                <a16:creationId xmlns:a16="http://schemas.microsoft.com/office/drawing/2014/main" id="{5C816E29-40AB-1A94-6AF3-1EFBE9A23C4C}"/>
+              </a:ext>
+            </a:extLst>
+          </p:cNvPr>
+          <p:cNvCxnSpPr>
+            <a:stCxn id="7" idx="2"/>
+            <a:endCxn id="11" idx="0"/>
+          </p:cNvCxnSpPr>
+          <p:nvPr/>
+        </p:nvCxnSpPr>
+        <p:spPr>
+          <a:xfrm>
+            <a:off x="4570476" y="2971800"/>
+            <a:ext cx="649224" cy="658368"/>
+          </a:xfrm>
+          <a:prstGeom prst="straightConnector1">
+            <a:avLst/>
+          </a:prstGeom>
+          <a:ln>
+            <a:tailEnd type="triangle"/>
+          </a:ln>
+        </p:spPr>
+        <p:style>
+          <a:lnRef idx="2">
+            <a:schemeClr val="accent1"/>
+          </a:lnRef>
+          <a:fillRef idx="0">
+            <a:schemeClr val="accent1"/>
+          </a:fillRef>
+          <a:effectRef idx="1">
+            <a:schemeClr val="accent1"/>
+          </a:effectRef>
+          <a:fontRef idx="minor">
+            <a:schemeClr val="tx1"/>
+          </a:fontRef>
+        </p:style>
+      </p:cxnSp>
+      <p:sp>
+        <p:nvSpPr>
+          <p:cNvPr id="14" name="Rectangle 13">
+            <a:extLst>
+              <a:ext uri="{FF2B5EF4-FFF2-40B4-BE49-F238E27FC236}">
+                <a16:creationId xmlns:a16="http://schemas.microsoft.com/office/drawing/2014/main" id="{9DBB9C34-B401-F991-3496-3F0EC28218AE}"/>
+              </a:ext>
+            </a:extLst>
+          </p:cNvPr>
+          <p:cNvSpPr/>
+          <p:nvPr/>
+        </p:nvSpPr>
+        <p:spPr>
+          <a:xfrm>
+            <a:off x="6522716" y="1760220"/>
+            <a:ext cx="2203704" cy="704088"/>
+          </a:xfrm>
+          <a:prstGeom prst="rect">
+            <a:avLst/>
+          </a:prstGeom>
+        </p:spPr>
+        <p:style>
+          <a:lnRef idx="2">
+            <a:schemeClr val="accent1">
+              <a:shade val="15000"/>
+            </a:schemeClr>
+          </a:lnRef>
+          <a:fillRef idx="1">
+            <a:schemeClr val="accent1"/>
+          </a:fillRef>
+          <a:effectRef idx="0">
+            <a:schemeClr val="accent1"/>
+          </a:effectRef>
+          <a:fontRef idx="minor">
+            <a:schemeClr val="lt1"/>
+          </a:fontRef>
+        </p:style>
+        <p:txBody>
+          <a:bodyPr rtlCol="0" anchor="ctr"/>
+          <a:lstStyle/>
+          <a:p>
+            <a:pPr algn="ctr"/>
+            <a:r>
+              <a:rPr lang="en-GB" dirty="0"/>
+              <a:t>Analyse URL path</a:t>
+            </a:r>
+          </a:p>
+        </p:txBody>
+      </p:sp>
+      <p:cxnSp>
+        <p:nvCxnSpPr>
+          <p:cNvPr id="16" name="Straight Arrow Connector 15">
+            <a:extLst>
+              <a:ext uri="{FF2B5EF4-FFF2-40B4-BE49-F238E27FC236}">
+                <a16:creationId xmlns:a16="http://schemas.microsoft.com/office/drawing/2014/main" id="{359CF3E6-F859-BA73-63CD-7C29A86DC8C5}"/>
+              </a:ext>
+            </a:extLst>
+          </p:cNvPr>
+          <p:cNvCxnSpPr>
+            <a:stCxn id="7" idx="3"/>
+            <a:endCxn id="14" idx="1"/>
+          </p:cNvCxnSpPr>
+          <p:nvPr/>
+        </p:nvCxnSpPr>
+        <p:spPr>
+          <a:xfrm flipV="1">
+            <a:off x="5468112" y="2112264"/>
+            <a:ext cx="1054604" cy="548640"/>
+          </a:xfrm>
+          <a:prstGeom prst="straightConnector1">
+            <a:avLst/>
+          </a:prstGeom>
+          <a:ln>
+            <a:tailEnd type="triangle"/>
+          </a:ln>
+        </p:spPr>
+        <p:style>
+          <a:lnRef idx="2">
+            <a:schemeClr val="accent1"/>
+          </a:lnRef>
+          <a:fillRef idx="0">
+            <a:schemeClr val="accent1"/>
+          </a:fillRef>
+          <a:effectRef idx="1">
+            <a:schemeClr val="accent1"/>
+          </a:effectRef>
+          <a:fontRef idx="minor">
+            <a:schemeClr val="tx1"/>
+          </a:fontRef>
+        </p:style>
+      </p:cxnSp>
+      <p:sp>
+        <p:nvSpPr>
+          <p:cNvPr id="17" name="Rectangle 16">
+            <a:extLst>
+              <a:ext uri="{FF2B5EF4-FFF2-40B4-BE49-F238E27FC236}">
+                <a16:creationId xmlns:a16="http://schemas.microsoft.com/office/drawing/2014/main" id="{3694263D-84AF-D832-6AEE-138DA6EA4EBC}"/>
+              </a:ext>
+            </a:extLst>
+          </p:cNvPr>
+          <p:cNvSpPr/>
+          <p:nvPr/>
+        </p:nvSpPr>
+        <p:spPr>
+          <a:xfrm>
+            <a:off x="822964" y="2295144"/>
+            <a:ext cx="1795272" cy="813816"/>
+          </a:xfrm>
+          <a:prstGeom prst="rect">
+            <a:avLst/>
+          </a:prstGeom>
+        </p:spPr>
+        <p:style>
+          <a:lnRef idx="2">
+            <a:schemeClr val="accent1">
+              <a:shade val="15000"/>
+            </a:schemeClr>
+          </a:lnRef>
+          <a:fillRef idx="1">
+            <a:schemeClr val="accent1"/>
+          </a:fillRef>
+          <a:effectRef idx="0">
+            <a:schemeClr val="accent1"/>
+          </a:effectRef>
+          <a:fontRef idx="minor">
+            <a:schemeClr val="lt1"/>
+          </a:fontRef>
+        </p:style>
+        <p:txBody>
+          <a:bodyPr rtlCol="0" anchor="ctr"/>
+          <a:lstStyle/>
+          <a:p>
+            <a:pPr algn="ctr"/>
+            <a:r>
+              <a:rPr lang="en-GB" dirty="0"/>
+              <a:t>Analyse country of registration</a:t>
+            </a:r>
+          </a:p>
+        </p:txBody>
+      </p:sp>
+      <p:cxnSp>
+        <p:nvCxnSpPr>
+          <p:cNvPr id="19" name="Straight Arrow Connector 18">
+            <a:extLst>
+              <a:ext uri="{FF2B5EF4-FFF2-40B4-BE49-F238E27FC236}">
+                <a16:creationId xmlns:a16="http://schemas.microsoft.com/office/drawing/2014/main" id="{C7F7DB0C-660A-A72A-BF7F-375DD7F4B36E}"/>
+              </a:ext>
+            </a:extLst>
+          </p:cNvPr>
+          <p:cNvCxnSpPr>
+            <a:cxnSpLocks/>
+            <a:stCxn id="7" idx="1"/>
+            <a:endCxn id="17" idx="3"/>
+          </p:cNvCxnSpPr>
+          <p:nvPr/>
+        </p:nvCxnSpPr>
+        <p:spPr>
+          <a:xfrm flipH="1">
+            <a:off x="2618236" y="2660904"/>
+            <a:ext cx="1054604" cy="41148"/>
+          </a:xfrm>
+          <a:prstGeom prst="straightConnector1">
+            <a:avLst/>
+          </a:prstGeom>
+          <a:ln>
+            <a:tailEnd type="triangle"/>
+          </a:ln>
+        </p:spPr>
+        <p:style>
+          <a:lnRef idx="2">
+            <a:schemeClr val="accent1"/>
+          </a:lnRef>
+          <a:fillRef idx="0">
+            <a:schemeClr val="accent1"/>
+          </a:fillRef>
+          <a:effectRef idx="1">
+            <a:schemeClr val="accent1"/>
+          </a:effectRef>
+          <a:fontRef idx="minor">
+            <a:schemeClr val="tx1"/>
+          </a:fontRef>
+        </p:style>
+      </p:cxnSp>
+      <p:sp>
+        <p:nvSpPr>
+          <p:cNvPr id="24" name="Rectangle 23">
+            <a:extLst>
+              <a:ext uri="{FF2B5EF4-FFF2-40B4-BE49-F238E27FC236}">
+                <a16:creationId xmlns:a16="http://schemas.microsoft.com/office/drawing/2014/main" id="{BDE3A1D6-1282-1CBA-39F2-BE7C89465A5A}"/>
+              </a:ext>
+            </a:extLst>
+          </p:cNvPr>
+          <p:cNvSpPr/>
+          <p:nvPr/>
+        </p:nvSpPr>
+        <p:spPr>
+          <a:xfrm>
+            <a:off x="439683" y="4690873"/>
+            <a:ext cx="1589532" cy="813816"/>
+          </a:xfrm>
+          <a:prstGeom prst="rect">
+            <a:avLst/>
+          </a:prstGeom>
+        </p:spPr>
+        <p:style>
+          <a:lnRef idx="2">
+            <a:schemeClr val="accent1">
+              <a:shade val="15000"/>
+            </a:schemeClr>
+          </a:lnRef>
+          <a:fillRef idx="1">
+            <a:schemeClr val="accent1"/>
+          </a:fillRef>
+          <a:effectRef idx="0">
+            <a:schemeClr val="accent1"/>
+          </a:effectRef>
+          <a:fontRef idx="minor">
+            <a:schemeClr val="lt1"/>
+          </a:fontRef>
+        </p:style>
+        <p:txBody>
+          <a:bodyPr rtlCol="0" anchor="ctr"/>
+          <a:lstStyle/>
+          <a:p>
+            <a:pPr algn="ctr"/>
+            <a:r>
+              <a:rPr lang="en-GB" dirty="0"/>
+              <a:t>Analyse Age</a:t>
+            </a:r>
+          </a:p>
+        </p:txBody>
+      </p:sp>
+      <p:cxnSp>
+        <p:nvCxnSpPr>
+          <p:cNvPr id="26" name="Straight Arrow Connector 25">
+            <a:extLst>
+              <a:ext uri="{FF2B5EF4-FFF2-40B4-BE49-F238E27FC236}">
+                <a16:creationId xmlns:a16="http://schemas.microsoft.com/office/drawing/2014/main" id="{8625E52E-896B-943B-628E-37A56C7B3B29}"/>
+              </a:ext>
+            </a:extLst>
+          </p:cNvPr>
+          <p:cNvCxnSpPr>
+            <a:stCxn id="6" idx="1"/>
+            <a:endCxn id="24" idx="0"/>
+          </p:cNvCxnSpPr>
+          <p:nvPr/>
+        </p:nvCxnSpPr>
+        <p:spPr>
+          <a:xfrm flipH="1">
+            <a:off x="1234449" y="3977640"/>
+            <a:ext cx="919342" cy="713233"/>
+          </a:xfrm>
+          <a:prstGeom prst="straightConnector1">
+            <a:avLst/>
+          </a:prstGeom>
+          <a:ln>
+            <a:tailEnd type="triangle"/>
+          </a:ln>
+        </p:spPr>
+        <p:style>
+          <a:lnRef idx="2">
+            <a:schemeClr val="accent1"/>
+          </a:lnRef>
+          <a:fillRef idx="0">
+            <a:schemeClr val="accent1"/>
+          </a:fillRef>
+          <a:effectRef idx="1">
+            <a:schemeClr val="accent1"/>
+          </a:effectRef>
+          <a:fontRef idx="minor">
+            <a:schemeClr val="tx1"/>
+          </a:fontRef>
+        </p:style>
+      </p:cxnSp>
+      <p:sp>
+        <p:nvSpPr>
+          <p:cNvPr id="27" name="Rectangle 26">
+            <a:extLst>
+              <a:ext uri="{FF2B5EF4-FFF2-40B4-BE49-F238E27FC236}">
+                <a16:creationId xmlns:a16="http://schemas.microsoft.com/office/drawing/2014/main" id="{B410E2B4-2759-9035-C372-004EEF724F5B}"/>
+              </a:ext>
+            </a:extLst>
+          </p:cNvPr>
+          <p:cNvSpPr/>
+          <p:nvPr/>
+        </p:nvSpPr>
+        <p:spPr>
+          <a:xfrm>
+            <a:off x="2186178" y="4713732"/>
+            <a:ext cx="1589532" cy="813816"/>
+          </a:xfrm>
+          <a:prstGeom prst="rect">
+            <a:avLst/>
+          </a:prstGeom>
+        </p:spPr>
+        <p:style>
+          <a:lnRef idx="2">
+            <a:schemeClr val="accent1">
+              <a:shade val="15000"/>
+            </a:schemeClr>
+          </a:lnRef>
+          <a:fillRef idx="1">
+            <a:schemeClr val="accent1"/>
+          </a:fillRef>
+          <a:effectRef idx="0">
+            <a:schemeClr val="accent1"/>
+          </a:effectRef>
+          <a:fontRef idx="minor">
+            <a:schemeClr val="lt1"/>
+          </a:fontRef>
+        </p:style>
+        <p:txBody>
+          <a:bodyPr rtlCol="0" anchor="ctr"/>
+          <a:lstStyle/>
+          <a:p>
+            <a:pPr algn="ctr"/>
+            <a:r>
+              <a:rPr lang="en-GB" dirty="0"/>
+              <a:t>Expiration Date of Certificate</a:t>
+            </a:r>
+          </a:p>
+        </p:txBody>
+      </p:sp>
+      <p:cxnSp>
+        <p:nvCxnSpPr>
+          <p:cNvPr id="29" name="Straight Arrow Connector 28">
+            <a:extLst>
+              <a:ext uri="{FF2B5EF4-FFF2-40B4-BE49-F238E27FC236}">
+                <a16:creationId xmlns:a16="http://schemas.microsoft.com/office/drawing/2014/main" id="{1F108960-C0AF-C4CF-3630-5AC95FD3473C}"/>
+              </a:ext>
+            </a:extLst>
+          </p:cNvPr>
+          <p:cNvCxnSpPr>
+            <a:stCxn id="6" idx="2"/>
+            <a:endCxn id="27" idx="0"/>
+          </p:cNvCxnSpPr>
+          <p:nvPr/>
+        </p:nvCxnSpPr>
+        <p:spPr>
+          <a:xfrm flipH="1">
+            <a:off x="2980944" y="4347972"/>
+            <a:ext cx="49147" cy="365760"/>
+          </a:xfrm>
+          <a:prstGeom prst="straightConnector1">
+            <a:avLst/>
+          </a:prstGeom>
+          <a:ln>
+            <a:tailEnd type="triangle"/>
+          </a:ln>
+        </p:spPr>
+        <p:style>
+          <a:lnRef idx="2">
+            <a:schemeClr val="accent1"/>
+          </a:lnRef>
+          <a:fillRef idx="0">
+            <a:schemeClr val="accent1"/>
+          </a:fillRef>
+          <a:effectRef idx="1">
+            <a:schemeClr val="accent1"/>
+          </a:effectRef>
+          <a:fontRef idx="minor">
+            <a:schemeClr val="tx1"/>
+          </a:fontRef>
+        </p:style>
+      </p:cxnSp>
+      <p:sp>
+        <p:nvSpPr>
+          <p:cNvPr id="30" name="Rectangle 29">
+            <a:extLst>
+              <a:ext uri="{FF2B5EF4-FFF2-40B4-BE49-F238E27FC236}">
+                <a16:creationId xmlns:a16="http://schemas.microsoft.com/office/drawing/2014/main" id="{593540D8-EF68-1F25-66B4-347D91287FC7}"/>
+              </a:ext>
+            </a:extLst>
+          </p:cNvPr>
+          <p:cNvSpPr/>
+          <p:nvPr/>
+        </p:nvSpPr>
+        <p:spPr>
+          <a:xfrm>
+            <a:off x="6597400" y="2756916"/>
+            <a:ext cx="2203704" cy="704088"/>
+          </a:xfrm>
+          <a:prstGeom prst="rect">
+            <a:avLst/>
+          </a:prstGeom>
+        </p:spPr>
+        <p:style>
+          <a:lnRef idx="2">
+            <a:schemeClr val="accent1">
+              <a:shade val="15000"/>
+            </a:schemeClr>
+          </a:lnRef>
+          <a:fillRef idx="1">
+            <a:schemeClr val="accent1"/>
+          </a:fillRef>
+          <a:effectRef idx="0">
+            <a:schemeClr val="accent1"/>
+          </a:effectRef>
+          <a:fontRef idx="minor">
+            <a:schemeClr val="lt1"/>
+          </a:fontRef>
+        </p:style>
+        <p:txBody>
+          <a:bodyPr rtlCol="0" anchor="ctr"/>
+          <a:lstStyle/>
+          <a:p>
+            <a:pPr algn="ctr"/>
+            <a:r>
+              <a:rPr lang="en-GB" dirty="0"/>
+              <a:t>Analyse URL protocol</a:t>
+            </a:r>
+          </a:p>
+        </p:txBody>
+      </p:sp>
+      <p:cxnSp>
+        <p:nvCxnSpPr>
+          <p:cNvPr id="33" name="Straight Arrow Connector 32">
+            <a:extLst>
+              <a:ext uri="{FF2B5EF4-FFF2-40B4-BE49-F238E27FC236}">
+                <a16:creationId xmlns:a16="http://schemas.microsoft.com/office/drawing/2014/main" id="{89231920-2B30-441E-6320-27348D7D4C0C}"/>
+              </a:ext>
+            </a:extLst>
+          </p:cNvPr>
+          <p:cNvCxnSpPr>
+            <a:stCxn id="7" idx="3"/>
+            <a:endCxn id="30" idx="1"/>
+          </p:cNvCxnSpPr>
+          <p:nvPr/>
+        </p:nvCxnSpPr>
+        <p:spPr>
+          <a:xfrm>
+            <a:off x="5468112" y="2660904"/>
+            <a:ext cx="1129288" cy="448056"/>
+          </a:xfrm>
+          <a:prstGeom prst="straightConnector1">
+            <a:avLst/>
+          </a:prstGeom>
+          <a:ln>
+            <a:tailEnd type="triangle"/>
+          </a:ln>
+        </p:spPr>
+        <p:style>
+          <a:lnRef idx="2">
+            <a:schemeClr val="accent1"/>
+          </a:lnRef>
+          <a:fillRef idx="0">
+            <a:schemeClr val="accent1"/>
+          </a:fillRef>
+          <a:effectRef idx="1">
+            <a:schemeClr val="accent1"/>
+          </a:effectRef>
+          <a:fontRef idx="minor">
+            <a:schemeClr val="tx1"/>
+          </a:fontRef>
+        </p:style>
+      </p:cxnSp>
+      <p:sp>
+        <p:nvSpPr>
+          <p:cNvPr id="34" name="Rectangle 33">
+            <a:extLst>
+              <a:ext uri="{FF2B5EF4-FFF2-40B4-BE49-F238E27FC236}">
+                <a16:creationId xmlns:a16="http://schemas.microsoft.com/office/drawing/2014/main" id="{3EC1FEBD-A8C5-FBE6-172A-B463C4E462BD}"/>
+              </a:ext>
+            </a:extLst>
+          </p:cNvPr>
+          <p:cNvSpPr/>
+          <p:nvPr/>
+        </p:nvSpPr>
+        <p:spPr>
+          <a:xfrm>
+            <a:off x="6244207" y="4713732"/>
+            <a:ext cx="2665482" cy="813816"/>
+          </a:xfrm>
+          <a:prstGeom prst="rect">
+            <a:avLst/>
+          </a:prstGeom>
+        </p:spPr>
+        <p:style>
+          <a:lnRef idx="2">
+            <a:schemeClr val="accent1">
+              <a:shade val="15000"/>
+            </a:schemeClr>
+          </a:lnRef>
+          <a:fillRef idx="1">
+            <a:schemeClr val="accent1"/>
+          </a:fillRef>
+          <a:effectRef idx="0">
+            <a:schemeClr val="accent1"/>
+          </a:effectRef>
+          <a:fontRef idx="minor">
+            <a:schemeClr val="lt1"/>
+          </a:fontRef>
+        </p:style>
+        <p:txBody>
+          <a:bodyPr rtlCol="0" anchor="ctr"/>
+          <a:lstStyle/>
+          <a:p>
+            <a:pPr algn="ctr"/>
+            <a:r>
+              <a:rPr lang="en-GB" dirty="0"/>
+              <a:t>Check (Link Text == Link) if not an image</a:t>
+            </a:r>
+          </a:p>
+        </p:txBody>
+      </p:sp>
+      <p:cxnSp>
+        <p:nvCxnSpPr>
+          <p:cNvPr id="36" name="Straight Arrow Connector 35">
+            <a:extLst>
+              <a:ext uri="{FF2B5EF4-FFF2-40B4-BE49-F238E27FC236}">
+                <a16:creationId xmlns:a16="http://schemas.microsoft.com/office/drawing/2014/main" id="{C9A6A39D-8D84-3585-9809-9DF620BCBB7C}"/>
+              </a:ext>
+            </a:extLst>
+          </p:cNvPr>
+          <p:cNvCxnSpPr>
+            <a:cxnSpLocks/>
+            <a:stCxn id="7" idx="3"/>
+            <a:endCxn id="34" idx="0"/>
+          </p:cNvCxnSpPr>
+          <p:nvPr/>
+        </p:nvCxnSpPr>
+        <p:spPr>
+          <a:xfrm>
+            <a:off x="5468112" y="2660904"/>
+            <a:ext cx="2108836" cy="2052828"/>
+          </a:xfrm>
+          <a:prstGeom prst="straightConnector1">
+            <a:avLst/>
+          </a:prstGeom>
+          <a:ln>
+            <a:tailEnd type="triangle"/>
+          </a:ln>
+        </p:spPr>
+        <p:style>
+          <a:lnRef idx="2">
+            <a:schemeClr val="accent1"/>
+          </a:lnRef>
+          <a:fillRef idx="0">
+            <a:schemeClr val="accent1"/>
+          </a:fillRef>
+          <a:effectRef idx="1">
+            <a:schemeClr val="accent1"/>
+          </a:effectRef>
+          <a:fontRef idx="minor">
+            <a:schemeClr val="tx1"/>
+          </a:fontRef>
+        </p:style>
+      </p:cxnSp>
+      <p:sp>
+        <p:nvSpPr>
+          <p:cNvPr id="54" name="Rectangle 53">
+            <a:extLst>
+              <a:ext uri="{FF2B5EF4-FFF2-40B4-BE49-F238E27FC236}">
+                <a16:creationId xmlns:a16="http://schemas.microsoft.com/office/drawing/2014/main" id="{954A85E0-551E-4438-E060-FE0D3F86417F}"/>
+              </a:ext>
+            </a:extLst>
+          </p:cNvPr>
+          <p:cNvSpPr/>
+          <p:nvPr/>
+        </p:nvSpPr>
+        <p:spPr>
+          <a:xfrm>
+            <a:off x="3854194" y="1207008"/>
+            <a:ext cx="1417322" cy="813816"/>
+          </a:xfrm>
+          <a:prstGeom prst="rect">
+            <a:avLst/>
+          </a:prstGeom>
+        </p:spPr>
+        <p:style>
+          <a:lnRef idx="2">
+            <a:schemeClr val="accent1">
+              <a:shade val="15000"/>
+            </a:schemeClr>
+          </a:lnRef>
+          <a:fillRef idx="1">
+            <a:schemeClr val="accent1"/>
+          </a:fillRef>
+          <a:effectRef idx="0">
+            <a:schemeClr val="accent1"/>
+          </a:effectRef>
+          <a:fontRef idx="minor">
+            <a:schemeClr val="lt1"/>
+          </a:fontRef>
+        </p:style>
+        <p:txBody>
+          <a:bodyPr rtlCol="0" anchor="ctr"/>
+          <a:lstStyle/>
+          <a:p>
+            <a:pPr algn="ctr"/>
+            <a:r>
+              <a:rPr lang="en-GB" dirty="0"/>
+              <a:t>Extend URL</a:t>
+            </a:r>
+          </a:p>
+        </p:txBody>
+      </p:sp>
+      <p:cxnSp>
+        <p:nvCxnSpPr>
+          <p:cNvPr id="56" name="Straight Arrow Connector 55">
+            <a:extLst>
+              <a:ext uri="{FF2B5EF4-FFF2-40B4-BE49-F238E27FC236}">
+                <a16:creationId xmlns:a16="http://schemas.microsoft.com/office/drawing/2014/main" id="{FBB76EB3-B7D2-B019-9BE7-B39D76035975}"/>
+              </a:ext>
+            </a:extLst>
+          </p:cNvPr>
+          <p:cNvCxnSpPr>
+            <a:stCxn id="5" idx="2"/>
+            <a:endCxn id="54" idx="0"/>
+          </p:cNvCxnSpPr>
+          <p:nvPr/>
+        </p:nvCxnSpPr>
+        <p:spPr>
+          <a:xfrm flipH="1">
+            <a:off x="4562855" y="836676"/>
+            <a:ext cx="7621" cy="370332"/>
+          </a:xfrm>
+          <a:prstGeom prst="straightConnector1">
+            <a:avLst/>
+          </a:prstGeom>
+          <a:ln>
+            <a:tailEnd type="triangle"/>
+          </a:ln>
+        </p:spPr>
+        <p:style>
+          <a:lnRef idx="2">
+            <a:schemeClr val="accent1"/>
+          </a:lnRef>
+          <a:fillRef idx="0">
+            <a:schemeClr val="accent1"/>
+          </a:fillRef>
+          <a:effectRef idx="1">
+            <a:schemeClr val="accent1"/>
+          </a:effectRef>
+          <a:fontRef idx="minor">
+            <a:schemeClr val="tx1"/>
+          </a:fontRef>
+        </p:style>
+      </p:cxnSp>
+      <p:sp>
+        <p:nvSpPr>
+          <p:cNvPr id="65" name="Rectangle 64">
+            <a:extLst>
+              <a:ext uri="{FF2B5EF4-FFF2-40B4-BE49-F238E27FC236}">
+                <a16:creationId xmlns:a16="http://schemas.microsoft.com/office/drawing/2014/main" id="{8B2C8710-FBE5-A9C5-DCFE-A15AA9F7348F}"/>
+              </a:ext>
+            </a:extLst>
+          </p:cNvPr>
+          <p:cNvSpPr/>
+          <p:nvPr/>
+        </p:nvSpPr>
+        <p:spPr>
+          <a:xfrm>
+            <a:off x="9015984" y="5591556"/>
+            <a:ext cx="2288277" cy="1088136"/>
+          </a:xfrm>
+          <a:prstGeom prst="rect">
+            <a:avLst/>
+          </a:prstGeom>
+        </p:spPr>
+        <p:style>
+          <a:lnRef idx="2">
+            <a:schemeClr val="accent1">
+              <a:shade val="15000"/>
+            </a:schemeClr>
+          </a:lnRef>
+          <a:fillRef idx="1">
+            <a:schemeClr val="accent1"/>
+          </a:fillRef>
+          <a:effectRef idx="0">
+            <a:schemeClr val="accent1"/>
+          </a:effectRef>
+          <a:fontRef idx="minor">
+            <a:schemeClr val="lt1"/>
+          </a:fontRef>
+        </p:style>
+        <p:txBody>
+          <a:bodyPr rtlCol="0" anchor="ctr"/>
+          <a:lstStyle/>
+          <a:p>
+            <a:pPr algn="ctr"/>
+            <a:r>
+              <a:rPr lang="en-GB" dirty="0"/>
+              <a:t>Combine Risk Scores</a:t>
+            </a:r>
+          </a:p>
+        </p:txBody>
+      </p:sp>
+      <p:cxnSp>
+        <p:nvCxnSpPr>
+          <p:cNvPr id="67" name="Straight Arrow Connector 66">
+            <a:extLst>
+              <a:ext uri="{FF2B5EF4-FFF2-40B4-BE49-F238E27FC236}">
+                <a16:creationId xmlns:a16="http://schemas.microsoft.com/office/drawing/2014/main" id="{BCFEE189-FDF4-54FE-5F4C-940B38B37E46}"/>
+              </a:ext>
+            </a:extLst>
+          </p:cNvPr>
+          <p:cNvCxnSpPr>
+            <a:cxnSpLocks/>
+            <a:stCxn id="11" idx="2"/>
+            <a:endCxn id="68" idx="0"/>
+          </p:cNvCxnSpPr>
+          <p:nvPr/>
+        </p:nvCxnSpPr>
+        <p:spPr>
+          <a:xfrm flipH="1">
+            <a:off x="4973956" y="4370832"/>
+            <a:ext cx="245744" cy="621792"/>
+          </a:xfrm>
+          <a:prstGeom prst="straightConnector1">
+            <a:avLst/>
+          </a:prstGeom>
+          <a:ln>
+            <a:tailEnd type="triangle"/>
+          </a:ln>
+        </p:spPr>
+        <p:style>
+          <a:lnRef idx="2">
+            <a:schemeClr val="accent1"/>
+          </a:lnRef>
+          <a:fillRef idx="0">
+            <a:schemeClr val="accent1"/>
+          </a:fillRef>
+          <a:effectRef idx="1">
+            <a:schemeClr val="accent1"/>
+          </a:effectRef>
+          <a:fontRef idx="minor">
+            <a:schemeClr val="tx1"/>
+          </a:fontRef>
+        </p:style>
+      </p:cxnSp>
+      <p:sp>
+        <p:nvSpPr>
+          <p:cNvPr id="68" name="Rectangle 67">
+            <a:extLst>
+              <a:ext uri="{FF2B5EF4-FFF2-40B4-BE49-F238E27FC236}">
+                <a16:creationId xmlns:a16="http://schemas.microsoft.com/office/drawing/2014/main" id="{A63621C1-845D-C40B-050F-CA867B1CC437}"/>
+              </a:ext>
+            </a:extLst>
+          </p:cNvPr>
+          <p:cNvSpPr/>
+          <p:nvPr/>
+        </p:nvSpPr>
+        <p:spPr>
+          <a:xfrm>
+            <a:off x="4258056" y="4992624"/>
+            <a:ext cx="1431800" cy="740664"/>
+          </a:xfrm>
+          <a:prstGeom prst="rect">
+            <a:avLst/>
+          </a:prstGeom>
+        </p:spPr>
+        <p:style>
+          <a:lnRef idx="2">
+            <a:schemeClr val="accent1">
+              <a:shade val="15000"/>
+            </a:schemeClr>
+          </a:lnRef>
+          <a:fillRef idx="1">
+            <a:schemeClr val="accent1"/>
+          </a:fillRef>
+          <a:effectRef idx="0">
+            <a:schemeClr val="accent1"/>
+          </a:effectRef>
+          <a:fontRef idx="minor">
+            <a:schemeClr val="lt1"/>
+          </a:fontRef>
+        </p:style>
+        <p:txBody>
+          <a:bodyPr rtlCol="0" anchor="ctr"/>
+          <a:lstStyle/>
+          <a:p>
+            <a:pPr algn="ctr"/>
+            <a:r>
+              <a:rPr lang="en-GB" dirty="0"/>
+              <a:t>Analyse data</a:t>
+            </a:r>
+          </a:p>
+        </p:txBody>
+      </p:sp>
+      <p:cxnSp>
+        <p:nvCxnSpPr>
+          <p:cNvPr id="71" name="Connector: Elbow 70">
+            <a:extLst>
+              <a:ext uri="{FF2B5EF4-FFF2-40B4-BE49-F238E27FC236}">
+                <a16:creationId xmlns:a16="http://schemas.microsoft.com/office/drawing/2014/main" id="{7EE3007D-01D3-866E-7D55-F0A1C0F8E0AE}"/>
+              </a:ext>
+            </a:extLst>
+          </p:cNvPr>
+          <p:cNvCxnSpPr>
+            <a:stCxn id="68" idx="2"/>
+            <a:endCxn id="65" idx="1"/>
+          </p:cNvCxnSpPr>
+          <p:nvPr/>
+        </p:nvCxnSpPr>
+        <p:spPr>
+          <a:xfrm rot="16200000" flipH="1">
+            <a:off x="6793802" y="3913442"/>
+            <a:ext cx="402336" cy="4042028"/>
+          </a:xfrm>
+          <a:prstGeom prst="bentConnector2">
+            <a:avLst/>
+          </a:prstGeom>
+          <a:ln>
+            <a:tailEnd type="triangle"/>
+          </a:ln>
+        </p:spPr>
+        <p:style>
+          <a:lnRef idx="2">
+            <a:schemeClr val="accent1"/>
+          </a:lnRef>
+          <a:fillRef idx="0">
+            <a:schemeClr val="accent1"/>
+          </a:fillRef>
+          <a:effectRef idx="1">
+            <a:schemeClr val="accent1"/>
+          </a:effectRef>
+          <a:fontRef idx="minor">
+            <a:schemeClr val="tx1"/>
+          </a:fontRef>
+        </p:style>
+      </p:cxnSp>
+      <p:cxnSp>
+        <p:nvCxnSpPr>
+          <p:cNvPr id="73" name="Connector: Elbow 72">
+            <a:extLst>
+              <a:ext uri="{FF2B5EF4-FFF2-40B4-BE49-F238E27FC236}">
+                <a16:creationId xmlns:a16="http://schemas.microsoft.com/office/drawing/2014/main" id="{38D40059-634E-B806-B8BF-D1B462DB506E}"/>
+              </a:ext>
+            </a:extLst>
+          </p:cNvPr>
+          <p:cNvCxnSpPr>
+            <a:stCxn id="34" idx="2"/>
+            <a:endCxn id="65" idx="1"/>
+          </p:cNvCxnSpPr>
+          <p:nvPr/>
+        </p:nvCxnSpPr>
+        <p:spPr>
+          <a:xfrm rot="16200000" flipH="1">
+            <a:off x="7992428" y="5112068"/>
+            <a:ext cx="608076" cy="1439036"/>
+          </a:xfrm>
+          <a:prstGeom prst="bentConnector2">
+            <a:avLst/>
+          </a:prstGeom>
+          <a:ln>
+            <a:tailEnd type="triangle"/>
+          </a:ln>
+        </p:spPr>
+        <p:style>
+          <a:lnRef idx="2">
+            <a:schemeClr val="accent1"/>
+          </a:lnRef>
+          <a:fillRef idx="0">
+            <a:schemeClr val="accent1"/>
+          </a:fillRef>
+          <a:effectRef idx="1">
+            <a:schemeClr val="accent1"/>
+          </a:effectRef>
+          <a:fontRef idx="minor">
+            <a:schemeClr val="tx1"/>
+          </a:fontRef>
+        </p:style>
+      </p:cxnSp>
+      <p:cxnSp>
+        <p:nvCxnSpPr>
+          <p:cNvPr id="75" name="Connector: Elbow 74">
+            <a:extLst>
+              <a:ext uri="{FF2B5EF4-FFF2-40B4-BE49-F238E27FC236}">
+                <a16:creationId xmlns:a16="http://schemas.microsoft.com/office/drawing/2014/main" id="{0682C2A0-A953-4256-0D77-342FB2B4C143}"/>
+              </a:ext>
+            </a:extLst>
+          </p:cNvPr>
+          <p:cNvCxnSpPr>
+            <a:stCxn id="30" idx="2"/>
+            <a:endCxn id="65" idx="0"/>
+          </p:cNvCxnSpPr>
+          <p:nvPr/>
+        </p:nvCxnSpPr>
+        <p:spPr>
+          <a:xfrm rot="16200000" flipH="1">
+            <a:off x="7864411" y="3295844"/>
+            <a:ext cx="2130552" cy="2460871"/>
+          </a:xfrm>
+          <a:prstGeom prst="bentConnector3">
+            <a:avLst/>
+          </a:prstGeom>
+          <a:ln>
+            <a:tailEnd type="triangle"/>
+          </a:ln>
+        </p:spPr>
+        <p:style>
+          <a:lnRef idx="2">
+            <a:schemeClr val="accent1"/>
+          </a:lnRef>
+          <a:fillRef idx="0">
+            <a:schemeClr val="accent1"/>
+          </a:fillRef>
+          <a:effectRef idx="1">
+            <a:schemeClr val="accent1"/>
+          </a:effectRef>
+          <a:fontRef idx="minor">
+            <a:schemeClr val="tx1"/>
+          </a:fontRef>
+        </p:style>
+      </p:cxnSp>
+      <p:cxnSp>
+        <p:nvCxnSpPr>
+          <p:cNvPr id="77" name="Connector: Elbow 76">
+            <a:extLst>
+              <a:ext uri="{FF2B5EF4-FFF2-40B4-BE49-F238E27FC236}">
+                <a16:creationId xmlns:a16="http://schemas.microsoft.com/office/drawing/2014/main" id="{25484E03-B330-630D-F12C-CA58D3D18869}"/>
+              </a:ext>
+            </a:extLst>
+          </p:cNvPr>
+          <p:cNvCxnSpPr>
+            <a:stCxn id="14" idx="3"/>
+            <a:endCxn id="65" idx="0"/>
+          </p:cNvCxnSpPr>
+          <p:nvPr/>
+        </p:nvCxnSpPr>
+        <p:spPr>
+          <a:xfrm>
+            <a:off x="8726420" y="2112264"/>
+            <a:ext cx="1433703" cy="3479292"/>
+          </a:xfrm>
+          <a:prstGeom prst="bentConnector2">
+            <a:avLst/>
+          </a:prstGeom>
+          <a:ln>
+            <a:tailEnd type="triangle"/>
+          </a:ln>
+        </p:spPr>
+        <p:style>
+          <a:lnRef idx="2">
+            <a:schemeClr val="accent1"/>
+          </a:lnRef>
+          <a:fillRef idx="0">
+            <a:schemeClr val="accent1"/>
+          </a:fillRef>
+          <a:effectRef idx="1">
+            <a:schemeClr val="accent1"/>
+          </a:effectRef>
+          <a:fontRef idx="minor">
+            <a:schemeClr val="tx1"/>
+          </a:fontRef>
+        </p:style>
+      </p:cxnSp>
+      <p:cxnSp>
+        <p:nvCxnSpPr>
+          <p:cNvPr id="79" name="Connector: Elbow 78">
+            <a:extLst>
+              <a:ext uri="{FF2B5EF4-FFF2-40B4-BE49-F238E27FC236}">
+                <a16:creationId xmlns:a16="http://schemas.microsoft.com/office/drawing/2014/main" id="{F6F34CD6-9FBF-30F9-721A-61B4F5BA3D3F}"/>
+              </a:ext>
+            </a:extLst>
+          </p:cNvPr>
+          <p:cNvCxnSpPr>
+            <a:stCxn id="27" idx="2"/>
+            <a:endCxn id="65" idx="1"/>
+          </p:cNvCxnSpPr>
+          <p:nvPr/>
+        </p:nvCxnSpPr>
+        <p:spPr>
+          <a:xfrm rot="16200000" flipH="1">
+            <a:off x="5694426" y="2814066"/>
+            <a:ext cx="608076" cy="6035040"/>
+          </a:xfrm>
+          <a:prstGeom prst="bentConnector2">
+            <a:avLst/>
+          </a:prstGeom>
+          <a:ln>
+            <a:tailEnd type="triangle"/>
+          </a:ln>
+        </p:spPr>
+        <p:style>
+          <a:lnRef idx="2">
+            <a:schemeClr val="accent1"/>
+          </a:lnRef>
+          <a:fillRef idx="0">
+            <a:schemeClr val="accent1"/>
+          </a:fillRef>
+          <a:effectRef idx="1">
+            <a:schemeClr val="accent1"/>
+          </a:effectRef>
+          <a:fontRef idx="minor">
+            <a:schemeClr val="tx1"/>
+          </a:fontRef>
+        </p:style>
+      </p:cxnSp>
+      <p:cxnSp>
+        <p:nvCxnSpPr>
+          <p:cNvPr id="81" name="Connector: Elbow 80">
+            <a:extLst>
+              <a:ext uri="{FF2B5EF4-FFF2-40B4-BE49-F238E27FC236}">
+                <a16:creationId xmlns:a16="http://schemas.microsoft.com/office/drawing/2014/main" id="{3C767E54-8798-DDFE-3BB7-A693837B6B07}"/>
+              </a:ext>
+            </a:extLst>
+          </p:cNvPr>
+          <p:cNvCxnSpPr>
+            <a:stCxn id="24" idx="2"/>
+            <a:endCxn id="65" idx="1"/>
+          </p:cNvCxnSpPr>
+          <p:nvPr/>
+        </p:nvCxnSpPr>
+        <p:spPr>
+          <a:xfrm rot="16200000" flipH="1">
+            <a:off x="4809749" y="1929388"/>
+            <a:ext cx="630935" cy="7781535"/>
+          </a:xfrm>
+          <a:prstGeom prst="bentConnector2">
+            <a:avLst/>
+          </a:prstGeom>
+          <a:ln>
+            <a:tailEnd type="triangle"/>
+          </a:ln>
+        </p:spPr>
+        <p:style>
+          <a:lnRef idx="2">
+            <a:schemeClr val="accent1"/>
+          </a:lnRef>
+          <a:fillRef idx="0">
+            <a:schemeClr val="accent1"/>
+          </a:fillRef>
+          <a:effectRef idx="1">
+            <a:schemeClr val="accent1"/>
+          </a:effectRef>
+          <a:fontRef idx="minor">
+            <a:schemeClr val="tx1"/>
+          </a:fontRef>
+        </p:style>
+      </p:cxnSp>
+      <p:cxnSp>
+        <p:nvCxnSpPr>
+          <p:cNvPr id="83" name="Connector: Elbow 82">
+            <a:extLst>
+              <a:ext uri="{FF2B5EF4-FFF2-40B4-BE49-F238E27FC236}">
+                <a16:creationId xmlns:a16="http://schemas.microsoft.com/office/drawing/2014/main" id="{86ED85D2-0DF7-D3FB-BA95-4418F6227ECE}"/>
+              </a:ext>
+            </a:extLst>
+          </p:cNvPr>
+          <p:cNvCxnSpPr>
+            <a:stCxn id="17" idx="1"/>
+            <a:endCxn id="65" idx="1"/>
+          </p:cNvCxnSpPr>
+          <p:nvPr/>
+        </p:nvCxnSpPr>
+        <p:spPr>
+          <a:xfrm rot="10800000" flipH="1" flipV="1">
+            <a:off x="822964" y="2702052"/>
+            <a:ext cx="8193020" cy="3433572"/>
+          </a:xfrm>
+          <a:prstGeom prst="bentConnector3">
+            <a:avLst>
+              <a:gd name="adj1" fmla="val -7031"/>
+            </a:avLst>
+          </a:prstGeom>
+          <a:ln>
+            <a:tailEnd type="triangle"/>
+          </a:ln>
+        </p:spPr>
+        <p:style>
+          <a:lnRef idx="2">
+            <a:schemeClr val="accent1"/>
+          </a:lnRef>
+          <a:fillRef idx="0">
+            <a:schemeClr val="accent1"/>
+          </a:fillRef>
+          <a:effectRef idx="1">
+            <a:schemeClr val="accent1"/>
+          </a:effectRef>
+          <a:fontRef idx="minor">
+            <a:schemeClr val="tx1"/>
+          </a:fontRef>
+        </p:style>
+      </p:cxnSp>
+      <p:sp>
+        <p:nvSpPr>
+          <p:cNvPr id="101" name="Rectangle 100">
+            <a:extLst>
+              <a:ext uri="{FF2B5EF4-FFF2-40B4-BE49-F238E27FC236}">
+                <a16:creationId xmlns:a16="http://schemas.microsoft.com/office/drawing/2014/main" id="{3A144460-88AA-3E85-7713-37DF98325417}"/>
+              </a:ext>
+            </a:extLst>
+          </p:cNvPr>
+          <p:cNvSpPr/>
+          <p:nvPr/>
+        </p:nvSpPr>
+        <p:spPr>
+          <a:xfrm>
+            <a:off x="9514713" y="553212"/>
+            <a:ext cx="2212848" cy="813816"/>
+          </a:xfrm>
+          <a:prstGeom prst="rect">
+            <a:avLst/>
+          </a:prstGeom>
+        </p:spPr>
+        <p:style>
+          <a:lnRef idx="2">
+            <a:schemeClr val="accent1">
+              <a:shade val="15000"/>
+            </a:schemeClr>
+          </a:lnRef>
+          <a:fillRef idx="1">
+            <a:schemeClr val="accent1"/>
+          </a:fillRef>
+          <a:effectRef idx="0">
+            <a:schemeClr val="accent1"/>
+          </a:effectRef>
+          <a:fontRef idx="minor">
+            <a:schemeClr val="lt1"/>
+          </a:fontRef>
+        </p:style>
+        <p:txBody>
+          <a:bodyPr rtlCol="0" anchor="ctr"/>
+          <a:lstStyle/>
+          <a:p>
+            <a:pPr algn="ctr"/>
+            <a:r>
+              <a:rPr lang="en-GB" dirty="0"/>
+              <a:t>Return Risk score for the URL to HTML CONTROLLER</a:t>
+            </a:r>
+          </a:p>
+        </p:txBody>
+      </p:sp>
+      <p:cxnSp>
+        <p:nvCxnSpPr>
+          <p:cNvPr id="107" name="Straight Arrow Connector 106">
+            <a:extLst>
+              <a:ext uri="{FF2B5EF4-FFF2-40B4-BE49-F238E27FC236}">
+                <a16:creationId xmlns:a16="http://schemas.microsoft.com/office/drawing/2014/main" id="{1ABF7B97-8933-69C9-D93E-FB47F5D398EC}"/>
+              </a:ext>
+            </a:extLst>
+          </p:cNvPr>
+          <p:cNvCxnSpPr>
+            <a:stCxn id="54" idx="2"/>
+            <a:endCxn id="7" idx="0"/>
+          </p:cNvCxnSpPr>
+          <p:nvPr/>
+        </p:nvCxnSpPr>
+        <p:spPr>
+          <a:xfrm>
+            <a:off x="4562855" y="2020824"/>
+            <a:ext cx="7621" cy="329184"/>
+          </a:xfrm>
+          <a:prstGeom prst="straightConnector1">
+            <a:avLst/>
+          </a:prstGeom>
+          <a:ln>
+            <a:tailEnd type="triangle"/>
+          </a:ln>
+        </p:spPr>
+        <p:style>
+          <a:lnRef idx="2">
+            <a:schemeClr val="accent1"/>
+          </a:lnRef>
+          <a:fillRef idx="0">
+            <a:schemeClr val="accent1"/>
+          </a:fillRef>
+          <a:effectRef idx="1">
+            <a:schemeClr val="accent1"/>
+          </a:effectRef>
+          <a:fontRef idx="minor">
+            <a:schemeClr val="tx1"/>
+          </a:fontRef>
+        </p:style>
+      </p:cxnSp>
+      <p:sp>
+        <p:nvSpPr>
+          <p:cNvPr id="110" name="Rectangle 109">
+            <a:extLst>
+              <a:ext uri="{FF2B5EF4-FFF2-40B4-BE49-F238E27FC236}">
+                <a16:creationId xmlns:a16="http://schemas.microsoft.com/office/drawing/2014/main" id="{B97A8192-A384-8695-9446-DC02167D6D53}"/>
+              </a:ext>
+            </a:extLst>
+          </p:cNvPr>
+          <p:cNvSpPr/>
+          <p:nvPr/>
+        </p:nvSpPr>
+        <p:spPr>
+          <a:xfrm>
+            <a:off x="920508" y="1380742"/>
+            <a:ext cx="1682487" cy="640082"/>
+          </a:xfrm>
+          <a:prstGeom prst="rect">
+            <a:avLst/>
+          </a:prstGeom>
+        </p:spPr>
+        <p:style>
+          <a:lnRef idx="2">
+            <a:schemeClr val="accent1">
+              <a:shade val="15000"/>
+            </a:schemeClr>
+          </a:lnRef>
+          <a:fillRef idx="1">
+            <a:schemeClr val="accent1"/>
+          </a:fillRef>
+          <a:effectRef idx="0">
+            <a:schemeClr val="accent1"/>
+          </a:effectRef>
+          <a:fontRef idx="minor">
+            <a:schemeClr val="lt1"/>
+          </a:fontRef>
+        </p:style>
+        <p:txBody>
+          <a:bodyPr rtlCol="0" anchor="ctr"/>
+          <a:lstStyle/>
+          <a:p>
+            <a:pPr algn="ctr"/>
+            <a:r>
+              <a:rPr lang="en-GB" dirty="0"/>
+              <a:t>Analyse Redirects</a:t>
+            </a:r>
+          </a:p>
+        </p:txBody>
+      </p:sp>
+      <p:cxnSp>
+        <p:nvCxnSpPr>
+          <p:cNvPr id="112" name="Straight Arrow Connector 111">
+            <a:extLst>
+              <a:ext uri="{FF2B5EF4-FFF2-40B4-BE49-F238E27FC236}">
+                <a16:creationId xmlns:a16="http://schemas.microsoft.com/office/drawing/2014/main" id="{3B78618B-5BB1-E52E-7776-3F171CAB0135}"/>
+              </a:ext>
+            </a:extLst>
+          </p:cNvPr>
+          <p:cNvCxnSpPr>
+            <a:stCxn id="54" idx="1"/>
+            <a:endCxn id="110" idx="3"/>
+          </p:cNvCxnSpPr>
+          <p:nvPr/>
+        </p:nvCxnSpPr>
+        <p:spPr>
+          <a:xfrm flipH="1">
+            <a:off x="2602995" y="1613916"/>
+            <a:ext cx="1251199" cy="86867"/>
+          </a:xfrm>
+          <a:prstGeom prst="straightConnector1">
+            <a:avLst/>
+          </a:prstGeom>
+          <a:ln>
+            <a:tailEnd type="triangle"/>
+          </a:ln>
+        </p:spPr>
+        <p:style>
+          <a:lnRef idx="2">
+            <a:schemeClr val="accent1"/>
+          </a:lnRef>
+          <a:fillRef idx="0">
+            <a:schemeClr val="accent1"/>
+          </a:fillRef>
+          <a:effectRef idx="1">
+            <a:schemeClr val="accent1"/>
+          </a:effectRef>
+          <a:fontRef idx="minor">
+            <a:schemeClr val="tx1"/>
+          </a:fontRef>
+        </p:style>
+      </p:cxnSp>
+      <p:cxnSp>
+        <p:nvCxnSpPr>
+          <p:cNvPr id="119" name="Connector: Elbow 118">
+            <a:extLst>
+              <a:ext uri="{FF2B5EF4-FFF2-40B4-BE49-F238E27FC236}">
+                <a16:creationId xmlns:a16="http://schemas.microsoft.com/office/drawing/2014/main" id="{6600ABC2-5B2C-7383-E3AF-2AA5E5342ADD}"/>
+              </a:ext>
+            </a:extLst>
+          </p:cNvPr>
+          <p:cNvCxnSpPr>
+            <a:stCxn id="110" idx="1"/>
+            <a:endCxn id="65" idx="1"/>
+          </p:cNvCxnSpPr>
+          <p:nvPr/>
+        </p:nvCxnSpPr>
+        <p:spPr>
+          <a:xfrm rot="10800000" flipH="1" flipV="1">
+            <a:off x="920508" y="1700782"/>
+            <a:ext cx="8095476" cy="4434841"/>
+          </a:xfrm>
+          <a:prstGeom prst="bentConnector3">
+            <a:avLst>
+              <a:gd name="adj1" fmla="val -8246"/>
+            </a:avLst>
+          </a:prstGeom>
+          <a:ln>
+            <a:tailEnd type="triangle"/>
+          </a:ln>
+        </p:spPr>
+        <p:style>
+          <a:lnRef idx="2">
+            <a:schemeClr val="accent1"/>
+          </a:lnRef>
+          <a:fillRef idx="0">
+            <a:schemeClr val="accent1"/>
+          </a:fillRef>
+          <a:effectRef idx="1">
+            <a:schemeClr val="accent1"/>
+          </a:effectRef>
+          <a:fontRef idx="minor">
+            <a:schemeClr val="tx1"/>
+          </a:fontRef>
+        </p:style>
+      </p:cxnSp>
+      <p:cxnSp>
+        <p:nvCxnSpPr>
+          <p:cNvPr id="122" name="Connector: Elbow 121">
+            <a:extLst>
+              <a:ext uri="{FF2B5EF4-FFF2-40B4-BE49-F238E27FC236}">
+                <a16:creationId xmlns:a16="http://schemas.microsoft.com/office/drawing/2014/main" id="{3ABD2528-B804-7C3C-FB52-D28B84840BB4}"/>
+              </a:ext>
+            </a:extLst>
+          </p:cNvPr>
+          <p:cNvCxnSpPr>
+            <a:stCxn id="65" idx="3"/>
+            <a:endCxn id="101" idx="2"/>
+          </p:cNvCxnSpPr>
+          <p:nvPr/>
+        </p:nvCxnSpPr>
+        <p:spPr>
+          <a:xfrm flipH="1" flipV="1">
+            <a:off x="10621137" y="1367028"/>
+            <a:ext cx="683124" cy="4768596"/>
+          </a:xfrm>
+          <a:prstGeom prst="bentConnector4">
+            <a:avLst>
+              <a:gd name="adj1" fmla="val -33464"/>
+              <a:gd name="adj2" fmla="val 55705"/>
+            </a:avLst>
+          </a:prstGeom>
+          <a:ln>
+            <a:tailEnd type="triangle"/>
+          </a:ln>
+        </p:spPr>
+        <p:style>
+          <a:lnRef idx="2">
+            <a:schemeClr val="accent1"/>
+          </a:lnRef>
+          <a:fillRef idx="0">
+            <a:schemeClr val="accent1"/>
+          </a:fillRef>
+          <a:effectRef idx="1">
+            <a:schemeClr val="accent1"/>
+          </a:effectRef>
+          <a:fontRef idx="minor">
+            <a:schemeClr val="tx1"/>
+          </a:fontRef>
+        </p:style>
+      </p:cxnSp>
+    </p:spTree>
+    <p:extLst>
+      <p:ext uri="{BB962C8B-B14F-4D97-AF65-F5344CB8AC3E}">
+        <p14:creationId xmlns:p14="http://schemas.microsoft.com/office/powerpoint/2010/main" val="2345528428"/>
+      </p:ext>
+    </p:extLst>
+  </p:cSld>
+  <p:clrMapOvr>
+    <a:masterClrMapping/>
+  </p:clrMapOvr>
+</p:sld>
+</file>
+
+<file path=ppt/slides/slide5.xml><?xml version="1.0" encoding="utf-8"?>
+<p:sld xmlns:a="http://schemas.openxmlformats.org/drawingml/2006/main" xmlns:r="http://schemas.openxmlformats.org/officeDocument/2006/relationships" xmlns:p="http://schemas.openxmlformats.org/presentationml/2006/main">
+  <p:cSld>
+    <p:spTree>
+      <p:nvGrpSpPr>
+        <p:cNvPr id="1" name=""/>
+        <p:cNvGrpSpPr/>
+        <p:nvPr/>
+      </p:nvGrpSpPr>
+      <p:grpSpPr>
+        <a:xfrm>
+          <a:off x="0" y="0"/>
+          <a:ext cx="0" cy="0"/>
+          <a:chOff x="0" y="0"/>
+          <a:chExt cx="0" cy="0"/>
+        </a:xfrm>
+      </p:grpSpPr>
+      <p:sp>
+        <p:nvSpPr>
+          <p:cNvPr id="4" name="Rectangle 3">
+            <a:extLst>
+              <a:ext uri="{FF2B5EF4-FFF2-40B4-BE49-F238E27FC236}">
+                <a16:creationId xmlns:a16="http://schemas.microsoft.com/office/drawing/2014/main" id="{317F0C95-202B-CE8A-C120-0769E5FB0AA9}"/>
+              </a:ext>
+            </a:extLst>
+          </p:cNvPr>
+          <p:cNvSpPr/>
+          <p:nvPr/>
+        </p:nvSpPr>
+        <p:spPr>
+          <a:xfrm>
+            <a:off x="0" y="0"/>
+            <a:ext cx="2331720" cy="813816"/>
+          </a:xfrm>
+          <a:prstGeom prst="rect">
+            <a:avLst/>
+          </a:prstGeom>
+        </p:spPr>
+        <p:style>
+          <a:lnRef idx="2">
+            <a:schemeClr val="accent1">
+              <a:shade val="15000"/>
+            </a:schemeClr>
+          </a:lnRef>
+          <a:fillRef idx="1">
+            <a:schemeClr val="accent1"/>
+          </a:fillRef>
+          <a:effectRef idx="0">
+            <a:schemeClr val="accent1"/>
+          </a:effectRef>
+          <a:fontRef idx="minor">
+            <a:schemeClr val="lt1"/>
+          </a:fontRef>
+        </p:style>
+        <p:txBody>
+          <a:bodyPr rtlCol="0" anchor="ctr"/>
+          <a:lstStyle/>
+          <a:p>
+            <a:pPr algn="ctr"/>
+            <a:r>
+              <a:rPr lang="en-GB" dirty="0"/>
+              <a:t>Bad Words Highlighting</a:t>
+            </a:r>
+          </a:p>
+        </p:txBody>
+      </p:sp>
+      <p:sp>
+        <p:nvSpPr>
+          <p:cNvPr id="5" name="Rectangle 4">
+            <a:extLst>
+              <a:ext uri="{FF2B5EF4-FFF2-40B4-BE49-F238E27FC236}">
+                <a16:creationId xmlns:a16="http://schemas.microsoft.com/office/drawing/2014/main" id="{B1D42FF9-D369-4C76-7415-DBFE472192AC}"/>
+              </a:ext>
+            </a:extLst>
+          </p:cNvPr>
+          <p:cNvSpPr/>
+          <p:nvPr/>
+        </p:nvSpPr>
+        <p:spPr>
+          <a:xfrm>
+            <a:off x="4023360" y="164592"/>
+            <a:ext cx="2072640" cy="813816"/>
+          </a:xfrm>
+          <a:prstGeom prst="rect">
+            <a:avLst/>
+          </a:prstGeom>
+        </p:spPr>
+        <p:style>
+          <a:lnRef idx="2">
+            <a:schemeClr val="accent1">
+              <a:shade val="15000"/>
+            </a:schemeClr>
+          </a:lnRef>
+          <a:fillRef idx="1">
+            <a:schemeClr val="accent1"/>
+          </a:fillRef>
+          <a:effectRef idx="0">
+            <a:schemeClr val="accent1"/>
+          </a:effectRef>
+          <a:fontRef idx="minor">
+            <a:schemeClr val="lt1"/>
+          </a:fontRef>
+        </p:style>
+        <p:txBody>
+          <a:bodyPr rtlCol="0" anchor="ctr"/>
+          <a:lstStyle/>
+          <a:p>
+            <a:pPr algn="ctr"/>
+            <a:r>
+              <a:rPr lang="en-GB" dirty="0"/>
+              <a:t>Email Body Received</a:t>
+            </a:r>
+          </a:p>
+        </p:txBody>
+      </p:sp>
+      <p:sp>
+        <p:nvSpPr>
+          <p:cNvPr id="6" name="Rectangle 5">
+            <a:extLst>
+              <a:ext uri="{FF2B5EF4-FFF2-40B4-BE49-F238E27FC236}">
+                <a16:creationId xmlns:a16="http://schemas.microsoft.com/office/drawing/2014/main" id="{873A3291-FFFB-7C24-9991-DE111964C1DD}"/>
+              </a:ext>
+            </a:extLst>
+          </p:cNvPr>
+          <p:cNvSpPr/>
+          <p:nvPr/>
+        </p:nvSpPr>
+        <p:spPr>
+          <a:xfrm>
+            <a:off x="4023360" y="1325880"/>
+            <a:ext cx="2072640" cy="1353312"/>
+          </a:xfrm>
+          <a:prstGeom prst="rect">
+            <a:avLst/>
+          </a:prstGeom>
+        </p:spPr>
+        <p:style>
+          <a:lnRef idx="2">
+            <a:schemeClr val="accent1">
+              <a:shade val="15000"/>
+            </a:schemeClr>
+          </a:lnRef>
+          <a:fillRef idx="1">
+            <a:schemeClr val="accent1"/>
+          </a:fillRef>
+          <a:effectRef idx="0">
+            <a:schemeClr val="accent1"/>
+          </a:effectRef>
+          <a:fontRef idx="minor">
+            <a:schemeClr val="lt1"/>
+          </a:fontRef>
+        </p:style>
+        <p:txBody>
+          <a:bodyPr rtlCol="0" anchor="ctr"/>
+          <a:lstStyle/>
+          <a:p>
+            <a:pPr algn="ctr"/>
+            <a:r>
+              <a:rPr lang="en-GB" dirty="0"/>
+              <a:t>Scan the body and isolate each word that is in the Bad Words Local </a:t>
+            </a:r>
+            <a:r>
+              <a:rPr lang="en-GB" dirty="0" err="1"/>
+              <a:t>db</a:t>
+            </a:r>
+            <a:endParaRPr lang="en-GB" dirty="0"/>
+          </a:p>
+        </p:txBody>
+      </p:sp>
+      <p:sp>
+        <p:nvSpPr>
+          <p:cNvPr id="7" name="Rectangle 6">
+            <a:extLst>
+              <a:ext uri="{FF2B5EF4-FFF2-40B4-BE49-F238E27FC236}">
+                <a16:creationId xmlns:a16="http://schemas.microsoft.com/office/drawing/2014/main" id="{B25CD4E1-34BA-F8FB-A4DF-D904392D206F}"/>
+              </a:ext>
+            </a:extLst>
+          </p:cNvPr>
+          <p:cNvSpPr/>
+          <p:nvPr/>
+        </p:nvSpPr>
+        <p:spPr>
+          <a:xfrm>
+            <a:off x="6867144" y="283464"/>
+            <a:ext cx="1115568" cy="722376"/>
+          </a:xfrm>
+          <a:prstGeom prst="rect">
+            <a:avLst/>
+          </a:prstGeom>
+        </p:spPr>
+        <p:style>
+          <a:lnRef idx="2">
+            <a:schemeClr val="accent1">
+              <a:shade val="15000"/>
+            </a:schemeClr>
+          </a:lnRef>
+          <a:fillRef idx="1">
+            <a:schemeClr val="accent1"/>
+          </a:fillRef>
+          <a:effectRef idx="0">
+            <a:schemeClr val="accent1"/>
+          </a:effectRef>
+          <a:fontRef idx="minor">
+            <a:schemeClr val="lt1"/>
+          </a:fontRef>
+        </p:style>
+        <p:txBody>
+          <a:bodyPr rtlCol="0" anchor="ctr"/>
+          <a:lstStyle/>
+          <a:p>
+            <a:pPr algn="ctr"/>
+            <a:r>
+              <a:rPr lang="en-GB" dirty="0"/>
+              <a:t>BAD words list</a:t>
+            </a:r>
+          </a:p>
+        </p:txBody>
+      </p:sp>
+      <p:sp>
+        <p:nvSpPr>
+          <p:cNvPr id="8" name="Rectangle 7">
+            <a:extLst>
+              <a:ext uri="{FF2B5EF4-FFF2-40B4-BE49-F238E27FC236}">
+                <a16:creationId xmlns:a16="http://schemas.microsoft.com/office/drawing/2014/main" id="{AEE8AA82-0432-1F38-8A49-D4F289728FD2}"/>
+              </a:ext>
+            </a:extLst>
+          </p:cNvPr>
+          <p:cNvSpPr/>
+          <p:nvPr/>
+        </p:nvSpPr>
+        <p:spPr>
+          <a:xfrm>
+            <a:off x="4064508" y="3136392"/>
+            <a:ext cx="1990344" cy="1435608"/>
+          </a:xfrm>
+          <a:prstGeom prst="rect">
+            <a:avLst/>
+          </a:prstGeom>
+        </p:spPr>
+        <p:style>
+          <a:lnRef idx="2">
+            <a:schemeClr val="accent1">
+              <a:shade val="15000"/>
+            </a:schemeClr>
+          </a:lnRef>
+          <a:fillRef idx="1">
+            <a:schemeClr val="accent1"/>
+          </a:fillRef>
+          <a:effectRef idx="0">
+            <a:schemeClr val="accent1"/>
+          </a:effectRef>
+          <a:fontRef idx="minor">
+            <a:schemeClr val="lt1"/>
+          </a:fontRef>
+        </p:style>
+        <p:txBody>
+          <a:bodyPr rtlCol="0" anchor="ctr"/>
+          <a:lstStyle/>
+          <a:p>
+            <a:pPr algn="ctr"/>
+            <a:r>
+              <a:rPr lang="en-GB" dirty="0"/>
+              <a:t>Inject custom CSS and add reason for the word/words being highlighted</a:t>
+            </a:r>
+          </a:p>
+        </p:txBody>
+      </p:sp>
+      <p:cxnSp>
+        <p:nvCxnSpPr>
+          <p:cNvPr id="10" name="Straight Arrow Connector 9">
+            <a:extLst>
+              <a:ext uri="{FF2B5EF4-FFF2-40B4-BE49-F238E27FC236}">
+                <a16:creationId xmlns:a16="http://schemas.microsoft.com/office/drawing/2014/main" id="{CD1A7AB4-9715-1962-F895-83CD6B4A1D9A}"/>
+              </a:ext>
+            </a:extLst>
+          </p:cNvPr>
+          <p:cNvCxnSpPr>
+            <a:stCxn id="6" idx="2"/>
+            <a:endCxn id="8" idx="0"/>
+          </p:cNvCxnSpPr>
+          <p:nvPr/>
+        </p:nvCxnSpPr>
+        <p:spPr>
+          <a:xfrm>
+            <a:off x="5059680" y="2679192"/>
+            <a:ext cx="0" cy="457200"/>
+          </a:xfrm>
+          <a:prstGeom prst="straightConnector1">
+            <a:avLst/>
+          </a:prstGeom>
+          <a:ln>
+            <a:tailEnd type="triangle"/>
+          </a:ln>
+        </p:spPr>
+        <p:style>
+          <a:lnRef idx="2">
+            <a:schemeClr val="accent1"/>
+          </a:lnRef>
+          <a:fillRef idx="0">
+            <a:schemeClr val="accent1"/>
+          </a:fillRef>
+          <a:effectRef idx="1">
+            <a:schemeClr val="accent1"/>
+          </a:effectRef>
+          <a:fontRef idx="minor">
+            <a:schemeClr val="tx1"/>
+          </a:fontRef>
+        </p:style>
+      </p:cxnSp>
+      <p:cxnSp>
+        <p:nvCxnSpPr>
+          <p:cNvPr id="12" name="Straight Arrow Connector 11">
+            <a:extLst>
+              <a:ext uri="{FF2B5EF4-FFF2-40B4-BE49-F238E27FC236}">
+                <a16:creationId xmlns:a16="http://schemas.microsoft.com/office/drawing/2014/main" id="{7C445217-7509-EABC-3FB1-B3791A9644FB}"/>
+              </a:ext>
+            </a:extLst>
+          </p:cNvPr>
+          <p:cNvCxnSpPr>
+            <a:stCxn id="6" idx="3"/>
+            <a:endCxn id="7" idx="2"/>
+          </p:cNvCxnSpPr>
+          <p:nvPr/>
+        </p:nvCxnSpPr>
+        <p:spPr>
+          <a:xfrm flipV="1">
+            <a:off x="6096000" y="1005840"/>
+            <a:ext cx="1328928" cy="996696"/>
+          </a:xfrm>
+          <a:prstGeom prst="straightConnector1">
+            <a:avLst/>
+          </a:prstGeom>
+          <a:ln>
+            <a:headEnd type="triangle"/>
+            <a:tailEnd type="triangle"/>
+          </a:ln>
+        </p:spPr>
+        <p:style>
+          <a:lnRef idx="2">
+            <a:schemeClr val="accent1"/>
+          </a:lnRef>
+          <a:fillRef idx="0">
+            <a:schemeClr val="accent1"/>
+          </a:fillRef>
+          <a:effectRef idx="1">
+            <a:schemeClr val="accent1"/>
+          </a:effectRef>
+          <a:fontRef idx="minor">
+            <a:schemeClr val="tx1"/>
+          </a:fontRef>
+        </p:style>
+      </p:cxnSp>
+      <p:cxnSp>
+        <p:nvCxnSpPr>
+          <p:cNvPr id="14" name="Straight Arrow Connector 13">
+            <a:extLst>
+              <a:ext uri="{FF2B5EF4-FFF2-40B4-BE49-F238E27FC236}">
+                <a16:creationId xmlns:a16="http://schemas.microsoft.com/office/drawing/2014/main" id="{11ECD445-1C34-DF80-867A-1BDABC5D3BA4}"/>
+              </a:ext>
+            </a:extLst>
+          </p:cNvPr>
+          <p:cNvCxnSpPr>
+            <a:stCxn id="5" idx="2"/>
+            <a:endCxn id="6" idx="0"/>
+          </p:cNvCxnSpPr>
+          <p:nvPr/>
+        </p:nvCxnSpPr>
+        <p:spPr>
+          <a:xfrm>
+            <a:off x="5059680" y="978408"/>
+            <a:ext cx="0" cy="347472"/>
+          </a:xfrm>
+          <a:prstGeom prst="straightConnector1">
+            <a:avLst/>
+          </a:prstGeom>
+          <a:ln>
+            <a:tailEnd type="triangle"/>
+          </a:ln>
+        </p:spPr>
+        <p:style>
+          <a:lnRef idx="2">
+            <a:schemeClr val="accent1"/>
+          </a:lnRef>
+          <a:fillRef idx="0">
+            <a:schemeClr val="accent1"/>
+          </a:fillRef>
+          <a:effectRef idx="1">
+            <a:schemeClr val="accent1"/>
+          </a:effectRef>
+          <a:fontRef idx="minor">
+            <a:schemeClr val="tx1"/>
+          </a:fontRef>
+        </p:style>
+      </p:cxnSp>
+    </p:spTree>
+    <p:extLst>
+      <p:ext uri="{BB962C8B-B14F-4D97-AF65-F5344CB8AC3E}">
+        <p14:creationId xmlns:p14="http://schemas.microsoft.com/office/powerpoint/2010/main" val="3429791048"/>
       </p:ext>
     </p:extLst>
   </p:cSld>

</xml_diff>